<commit_message>
created archive, new material for 2026
</commit_message>
<xml_diff>
--- a/Practical Secure AI.pptx
+++ b/Practical Secure AI.pptx
@@ -12,11 +12,11 @@
     <p:sldId id="258" r:id="rId3"/>
     <p:sldId id="265" r:id="rId4"/>
     <p:sldId id="257" r:id="rId5"/>
-    <p:sldId id="259" r:id="rId6"/>
-    <p:sldId id="260" r:id="rId7"/>
-    <p:sldId id="262" r:id="rId8"/>
-    <p:sldId id="263" r:id="rId9"/>
-    <p:sldId id="264" r:id="rId10"/>
+    <p:sldId id="266" r:id="rId6"/>
+    <p:sldId id="259" r:id="rId7"/>
+    <p:sldId id="260" r:id="rId8"/>
+    <p:sldId id="267" r:id="rId9"/>
+    <p:sldId id="262" r:id="rId10"/>
     <p:sldId id="261" r:id="rId11"/>
   </p:sldIdLst>
   <p:sldSz cx="12192000" cy="6858000"/>
@@ -206,7 +206,7 @@
           <a:p>
             <a:fld id="{EC15A5CC-CFD7-D24A-B172-9CF4BFC4F3A8}" type="datetimeFigureOut">
               <a:rPr lang="en-US" smtClean="0"/>
-              <a:t>5/7/25</a:t>
+              <a:t>5/5/26</a:t>
             </a:fld>
             <a:endParaRPr lang="en-US"/>
           </a:p>
@@ -501,6 +501,13 @@
           </p:nvPr>
         </p:nvSpPr>
         <p:spPr/>
+        <p:txBody>
+          <a:bodyPr/>
+          <a:lstStyle/>
+          <a:p>
+            <a:endParaRPr lang="en-US"/>
+          </a:p>
+        </p:txBody>
       </p:sp>
       <p:sp>
         <p:nvSpPr>
@@ -585,6 +592,13 @@
           </p:nvPr>
         </p:nvSpPr>
         <p:spPr/>
+        <p:txBody>
+          <a:bodyPr/>
+          <a:lstStyle/>
+          <a:p>
+            <a:endParaRPr lang="en-US"/>
+          </a:p>
+        </p:txBody>
       </p:sp>
       <p:sp>
         <p:nvSpPr>
@@ -669,6 +683,13 @@
           </p:nvPr>
         </p:nvSpPr>
         <p:spPr/>
+        <p:txBody>
+          <a:bodyPr/>
+          <a:lstStyle/>
+          <a:p>
+            <a:endParaRPr lang="en-US"/>
+          </a:p>
+        </p:txBody>
       </p:sp>
       <p:sp>
         <p:nvSpPr>
@@ -706,7 +727,7 @@
           <a:p>
             <a:fld id="{7C803E4F-2807-8A41-95DA-1D03DD8A0194}" type="slidenum">
               <a:rPr lang="en-US" smtClean="0"/>
-              <a:t>6</a:t>
+              <a:t>4</a:t>
             </a:fld>
             <a:endParaRPr lang="en-US"/>
           </a:p>
@@ -715,7 +736,7 @@
     </p:spTree>
     <p:extLst>
       <p:ext uri="{BB962C8B-B14F-4D97-AF65-F5344CB8AC3E}">
-        <p14:creationId xmlns:p14="http://schemas.microsoft.com/office/powerpoint/2010/main" val="3388986232"/>
+        <p14:creationId xmlns:p14="http://schemas.microsoft.com/office/powerpoint/2010/main" val="1959272662"/>
       </p:ext>
     </p:extLst>
   </p:cSld>
@@ -730,7 +751,13 @@
   <p:cSld>
     <p:spTree>
       <p:nvGrpSpPr>
-        <p:cNvPr id="1" name=""/>
+        <p:cNvPr id="1" name="">
+          <a:extLst>
+            <a:ext uri="{FF2B5EF4-FFF2-40B4-BE49-F238E27FC236}">
+              <a16:creationId xmlns:a16="http://schemas.microsoft.com/office/drawing/2014/main" id="{CBF22E93-32E2-7278-193E-4216919F989B}"/>
+            </a:ext>
+          </a:extLst>
+        </p:cNvPr>
         <p:cNvGrpSpPr/>
         <p:nvPr/>
       </p:nvGrpSpPr>
@@ -744,7 +771,13 @@
       </p:grpSpPr>
       <p:sp>
         <p:nvSpPr>
-          <p:cNvPr id="2" name="Slide Image Placeholder 1"/>
+          <p:cNvPr id="2" name="Slide Image Placeholder 1">
+            <a:extLst>
+              <a:ext uri="{FF2B5EF4-FFF2-40B4-BE49-F238E27FC236}">
+                <a16:creationId xmlns:a16="http://schemas.microsoft.com/office/drawing/2014/main" id="{06065DC7-30BA-CB88-251C-544E0ABDFD67}"/>
+              </a:ext>
+            </a:extLst>
+          </p:cNvPr>
           <p:cNvSpPr>
             <a:spLocks noGrp="1" noRot="1" noChangeAspect="1"/>
           </p:cNvSpPr>
@@ -753,10 +786,23 @@
           </p:nvPr>
         </p:nvSpPr>
         <p:spPr/>
-      </p:sp>
-      <p:sp>
-        <p:nvSpPr>
-          <p:cNvPr id="3" name="Notes Placeholder 2"/>
+        <p:txBody>
+          <a:bodyPr/>
+          <a:lstStyle/>
+          <a:p>
+            <a:endParaRPr lang="en-US"/>
+          </a:p>
+        </p:txBody>
+      </p:sp>
+      <p:sp>
+        <p:nvSpPr>
+          <p:cNvPr id="3" name="Notes Placeholder 2">
+            <a:extLst>
+              <a:ext uri="{FF2B5EF4-FFF2-40B4-BE49-F238E27FC236}">
+                <a16:creationId xmlns:a16="http://schemas.microsoft.com/office/drawing/2014/main" id="{B60BD6E0-55AA-27B8-3E18-8385225F0463}"/>
+              </a:ext>
+            </a:extLst>
+          </p:cNvPr>
           <p:cNvSpPr>
             <a:spLocks noGrp="1"/>
           </p:cNvSpPr>
@@ -769,509 +815,19 @@
           <a:bodyPr/>
           <a:lstStyle/>
           <a:p>
-            <a:r>
-              <a:rPr lang="en-US" b="0" i="0" u="none" strike="noStrike" dirty="0">
-                <a:solidFill>
-                  <a:srgbClr val="000000"/>
-                </a:solidFill>
-                <a:effectLst/>
-                <a:latin typeface="-webkit-standard"/>
-              </a:rPr>
-              <a:t>Quantization in LLMs is a technique used to reduce the memory footprint and computational cost of running large-scale neural networks by representing weights and activations with lower precision numerical formats (e.g., reducing from 32-bit floating point (FP32) to 8-bit integers (INT8) or lower).</a:t>
-            </a:r>
-          </a:p>
-          <a:p>
-            <a:endParaRPr lang="en-US" b="0" i="0" u="none" strike="noStrike" dirty="0">
-              <a:solidFill>
-                <a:srgbClr val="000000"/>
-              </a:solidFill>
-              <a:effectLst/>
-              <a:latin typeface="-webkit-standard"/>
-            </a:endParaRPr>
-          </a:p>
-          <a:p>
-            <a:r>
-              <a:rPr lang="en-US" b="0" i="0" u="none" strike="noStrike" dirty="0">
-                <a:solidFill>
-                  <a:srgbClr val="000000"/>
-                </a:solidFill>
-                <a:effectLst/>
-                <a:latin typeface="-webkit-standard"/>
-              </a:rPr>
-              <a:t>Quantization: </a:t>
-            </a:r>
-          </a:p>
-          <a:p>
-            <a:endParaRPr lang="en-US" b="0" i="0" u="none" strike="noStrike" dirty="0">
-              <a:solidFill>
-                <a:srgbClr val="000000"/>
-              </a:solidFill>
-              <a:effectLst/>
-              <a:latin typeface="-webkit-standard"/>
-            </a:endParaRPr>
-          </a:p>
-          <a:p>
-            <a:r>
-              <a:rPr lang="en-US" b="1" dirty="0"/>
-              <a:t>Reducing Model Size</a:t>
-            </a:r>
-            <a:r>
-              <a:rPr lang="en-US" dirty="0"/>
-              <a:t> – Uses less memory, allowing models to fit into smaller hardware (e.g., edge devices, consumer GPUs).</a:t>
-            </a:r>
-          </a:p>
-          <a:p>
-            <a:r>
-              <a:rPr lang="en-US" b="1" dirty="0"/>
-              <a:t>Speeding Up Inference</a:t>
-            </a:r>
-            <a:r>
-              <a:rPr lang="en-US" dirty="0"/>
-              <a:t> – Lower precision calculations are faster and consume less power.</a:t>
-            </a:r>
-          </a:p>
-          <a:p>
-            <a:r>
-              <a:rPr lang="en-US" b="1" dirty="0"/>
-              <a:t>Lowering Latency</a:t>
-            </a:r>
-            <a:r>
-              <a:rPr lang="en-US" dirty="0"/>
-              <a:t> – Essential for real-time applications like chatbots and AI assistants.</a:t>
-            </a:r>
-          </a:p>
-          <a:p>
-            <a:r>
-              <a:rPr lang="en-US" b="1" dirty="0"/>
-              <a:t>Reducing Energy Consumption</a:t>
-            </a:r>
-            <a:r>
-              <a:rPr lang="en-US" dirty="0"/>
-              <a:t> – Helps deploy AI models more efficiently on constrained hardware.</a:t>
-            </a:r>
-          </a:p>
-          <a:p>
             <a:endParaRPr lang="en-US" dirty="0"/>
           </a:p>
-          <a:p>
-            <a:endParaRPr lang="en-US" dirty="0"/>
-          </a:p>
-          <a:p>
-            <a:pPr algn="l"/>
-            <a:r>
-              <a:rPr lang="en-US" b="1" i="0" u="none" strike="noStrike" dirty="0">
-                <a:solidFill>
-                  <a:srgbClr val="000000"/>
-                </a:solidFill>
-                <a:effectLst/>
-              </a:rPr>
-              <a:t>Types of Quantization</a:t>
-            </a:r>
-          </a:p>
-          <a:p>
-            <a:pPr algn="l">
-              <a:buFont typeface="+mj-lt"/>
-              <a:buAutoNum type="arabicPeriod"/>
-            </a:pPr>
-            <a:r>
-              <a:rPr lang="en-US" b="1" i="0" u="none" strike="noStrike" dirty="0">
-                <a:solidFill>
-                  <a:srgbClr val="000000"/>
-                </a:solidFill>
-                <a:effectLst/>
-              </a:rPr>
-              <a:t>Post-Training Quantization (PTQ)</a:t>
-            </a:r>
-            <a:endParaRPr lang="en-US" b="0" i="0" u="none" strike="noStrike" dirty="0">
-              <a:solidFill>
-                <a:srgbClr val="000000"/>
-              </a:solidFill>
-              <a:effectLst/>
-            </a:endParaRPr>
-          </a:p>
-          <a:p>
-            <a:pPr marL="742950" lvl="1" indent="-285750" algn="l">
-              <a:buFont typeface="+mj-lt"/>
-              <a:buAutoNum type="arabicPeriod"/>
-            </a:pPr>
-            <a:r>
-              <a:rPr lang="en-US" b="0" i="0" u="none" strike="noStrike" dirty="0">
-                <a:solidFill>
-                  <a:srgbClr val="000000"/>
-                </a:solidFill>
-                <a:effectLst/>
-              </a:rPr>
-              <a:t>Applied after the model is trained.</a:t>
-            </a:r>
-          </a:p>
-          <a:p>
-            <a:pPr marL="742950" lvl="1" indent="-285750" algn="l">
-              <a:buFont typeface="+mj-lt"/>
-              <a:buAutoNum type="arabicPeriod"/>
-            </a:pPr>
-            <a:r>
-              <a:rPr lang="en-US" b="0" i="0" u="none" strike="noStrike" dirty="0">
-                <a:solidFill>
-                  <a:srgbClr val="000000"/>
-                </a:solidFill>
-                <a:effectLst/>
-              </a:rPr>
-              <a:t>Common in scenarios where retraining is expensive.</a:t>
-            </a:r>
-          </a:p>
-          <a:p>
-            <a:pPr marL="742950" lvl="1" indent="-285750" algn="l">
-              <a:buFont typeface="+mj-lt"/>
-              <a:buAutoNum type="arabicPeriod"/>
-            </a:pPr>
-            <a:r>
-              <a:rPr lang="en-US" b="0" i="0" u="none" strike="noStrike" dirty="0">
-                <a:solidFill>
-                  <a:srgbClr val="000000"/>
-                </a:solidFill>
-                <a:effectLst/>
-              </a:rPr>
-              <a:t>May lead to a slight accuracy drop but is widely used in deployment.</a:t>
-            </a:r>
-          </a:p>
-          <a:p>
-            <a:pPr algn="l">
-              <a:buFont typeface="+mj-lt"/>
-              <a:buAutoNum type="arabicPeriod"/>
-            </a:pPr>
-            <a:r>
-              <a:rPr lang="en-US" b="1" i="0" u="none" strike="noStrike" dirty="0">
-                <a:solidFill>
-                  <a:srgbClr val="000000"/>
-                </a:solidFill>
-                <a:effectLst/>
-              </a:rPr>
-              <a:t>Quantization-Aware Training (QAT)</a:t>
-            </a:r>
-            <a:endParaRPr lang="en-US" b="0" i="0" u="none" strike="noStrike" dirty="0">
-              <a:solidFill>
-                <a:srgbClr val="000000"/>
-              </a:solidFill>
-              <a:effectLst/>
-            </a:endParaRPr>
-          </a:p>
-          <a:p>
-            <a:pPr marL="742950" lvl="1" indent="-285750" algn="l">
-              <a:buFont typeface="+mj-lt"/>
-              <a:buAutoNum type="arabicPeriod"/>
-            </a:pPr>
-            <a:r>
-              <a:rPr lang="en-US" b="0" i="0" u="none" strike="noStrike" dirty="0">
-                <a:solidFill>
-                  <a:srgbClr val="000000"/>
-                </a:solidFill>
-                <a:effectLst/>
-              </a:rPr>
-              <a:t>Quantization is simulated during training so the model learns to adjust to lower precision.</a:t>
-            </a:r>
-          </a:p>
-          <a:p>
-            <a:pPr marL="742950" lvl="1" indent="-285750" algn="l">
-              <a:buFont typeface="+mj-lt"/>
-              <a:buAutoNum type="arabicPeriod"/>
-            </a:pPr>
-            <a:r>
-              <a:rPr lang="en-US" b="0" i="0" u="none" strike="noStrike" dirty="0">
-                <a:solidFill>
-                  <a:srgbClr val="000000"/>
-                </a:solidFill>
-                <a:effectLst/>
-              </a:rPr>
-              <a:t>More effective than PTQ in maintaining accuracy.</a:t>
-            </a:r>
-          </a:p>
-          <a:p>
-            <a:pPr marL="742950" lvl="1" indent="-285750" algn="l">
-              <a:buFont typeface="+mj-lt"/>
-              <a:buAutoNum type="arabicPeriod"/>
-            </a:pPr>
-            <a:r>
-              <a:rPr lang="en-US" b="0" i="0" u="none" strike="noStrike" dirty="0">
-                <a:solidFill>
-                  <a:srgbClr val="000000"/>
-                </a:solidFill>
-                <a:effectLst/>
-              </a:rPr>
-              <a:t>Requires more computational resources during training.</a:t>
-            </a:r>
-          </a:p>
-          <a:p>
-            <a:pPr algn="l">
-              <a:buFont typeface="+mj-lt"/>
-              <a:buAutoNum type="arabicPeriod"/>
-            </a:pPr>
-            <a:r>
-              <a:rPr lang="en-US" b="1" i="0" u="none" strike="noStrike" dirty="0">
-                <a:solidFill>
-                  <a:srgbClr val="000000"/>
-                </a:solidFill>
-                <a:effectLst/>
-              </a:rPr>
-              <a:t>Dynamic Quantization</a:t>
-            </a:r>
-            <a:endParaRPr lang="en-US" b="0" i="0" u="none" strike="noStrike" dirty="0">
-              <a:solidFill>
-                <a:srgbClr val="000000"/>
-              </a:solidFill>
-              <a:effectLst/>
-            </a:endParaRPr>
-          </a:p>
-          <a:p>
-            <a:pPr marL="742950" lvl="1" indent="-285750" algn="l">
-              <a:buFont typeface="+mj-lt"/>
-              <a:buAutoNum type="arabicPeriod"/>
-            </a:pPr>
-            <a:r>
-              <a:rPr lang="en-US" b="0" i="0" u="none" strike="noStrike" dirty="0">
-                <a:solidFill>
-                  <a:srgbClr val="000000"/>
-                </a:solidFill>
-                <a:effectLst/>
-              </a:rPr>
-              <a:t>Weights are quantized, but activations remain in full precision during inference.</a:t>
-            </a:r>
-          </a:p>
-          <a:p>
-            <a:pPr marL="742950" lvl="1" indent="-285750" algn="l">
-              <a:buFont typeface="+mj-lt"/>
-              <a:buAutoNum type="arabicPeriod"/>
-            </a:pPr>
-            <a:r>
-              <a:rPr lang="en-US" b="0" i="0" u="none" strike="noStrike" dirty="0">
-                <a:solidFill>
-                  <a:srgbClr val="000000"/>
-                </a:solidFill>
-                <a:effectLst/>
-              </a:rPr>
-              <a:t>Provides a balance between performance and accuracy.</a:t>
-            </a:r>
-          </a:p>
-          <a:p>
-            <a:pPr algn="l">
-              <a:buFont typeface="+mj-lt"/>
-              <a:buAutoNum type="arabicPeriod"/>
-            </a:pPr>
-            <a:r>
-              <a:rPr lang="en-US" b="1" i="0" u="none" strike="noStrike" dirty="0">
-                <a:solidFill>
-                  <a:srgbClr val="000000"/>
-                </a:solidFill>
-                <a:effectLst/>
-              </a:rPr>
-              <a:t>Mixed-Precision Quantization</a:t>
-            </a:r>
-            <a:endParaRPr lang="en-US" b="0" i="0" u="none" strike="noStrike" dirty="0">
-              <a:solidFill>
-                <a:srgbClr val="000000"/>
-              </a:solidFill>
-              <a:effectLst/>
-            </a:endParaRPr>
-          </a:p>
-          <a:p>
-            <a:pPr marL="742950" lvl="1" indent="-285750" algn="l">
-              <a:buFont typeface="+mj-lt"/>
-              <a:buAutoNum type="arabicPeriod"/>
-            </a:pPr>
-            <a:r>
-              <a:rPr lang="en-US" b="0" i="0" u="none" strike="noStrike" dirty="0">
-                <a:solidFill>
-                  <a:srgbClr val="000000"/>
-                </a:solidFill>
-                <a:effectLst/>
-              </a:rPr>
-              <a:t>Uses different bit precisions for different parts of the model (e.g., some layers in INT8, others in FP16).</a:t>
-            </a:r>
-          </a:p>
-          <a:p>
-            <a:pPr marL="742950" lvl="1" indent="-285750" algn="l">
-              <a:buFont typeface="+mj-lt"/>
-              <a:buAutoNum type="arabicPeriod"/>
-            </a:pPr>
-            <a:r>
-              <a:rPr lang="en-US" b="0" i="0" u="none" strike="noStrike" dirty="0">
-                <a:solidFill>
-                  <a:srgbClr val="000000"/>
-                </a:solidFill>
-                <a:effectLst/>
-              </a:rPr>
-              <a:t>Optimized for balancing efficiency and accuracy.</a:t>
-            </a:r>
-          </a:p>
-          <a:p>
-            <a:pPr marL="285750" lvl="0" indent="-285750" algn="l">
-              <a:buFont typeface="+mj-lt"/>
-              <a:buAutoNum type="arabicPeriod"/>
-            </a:pPr>
-            <a:endParaRPr lang="en-US" b="0" i="0" u="none" strike="noStrike" dirty="0">
-              <a:solidFill>
-                <a:srgbClr val="000000"/>
-              </a:solidFill>
-              <a:effectLst/>
-            </a:endParaRPr>
-          </a:p>
-          <a:p>
-            <a:pPr algn="l"/>
-            <a:r>
-              <a:rPr lang="en-US" b="0" i="0" u="none" strike="noStrike" dirty="0">
-                <a:solidFill>
-                  <a:srgbClr val="000000"/>
-                </a:solidFill>
-                <a:effectLst/>
-              </a:rPr>
-              <a:t>Distillation in Large Language Models (LLMs) refers to a </a:t>
-            </a:r>
-            <a:r>
-              <a:rPr lang="en-US" b="1" i="0" u="none" strike="noStrike" dirty="0">
-                <a:solidFill>
-                  <a:srgbClr val="000000"/>
-                </a:solidFill>
-                <a:effectLst/>
-              </a:rPr>
-              <a:t>knowledge transfer technique</a:t>
-            </a:r>
-            <a:r>
-              <a:rPr lang="en-US" b="0" i="0" u="none" strike="noStrike" dirty="0">
-                <a:solidFill>
-                  <a:srgbClr val="000000"/>
-                </a:solidFill>
-                <a:effectLst/>
-              </a:rPr>
-              <a:t> where a smaller, more efficient model (student model) learns from a larger, more powerful model (teacher model). This process helps compress the knowledge of the large model into a smaller one while maintaining performance.</a:t>
-            </a:r>
-          </a:p>
-          <a:p>
-            <a:pPr algn="l"/>
-            <a:r>
-              <a:rPr lang="en-US" b="1" i="0" u="none" strike="noStrike" dirty="0">
-                <a:solidFill>
-                  <a:srgbClr val="000000"/>
-                </a:solidFill>
-                <a:effectLst/>
-              </a:rPr>
-              <a:t>How Distillation Works in LLMs</a:t>
-            </a:r>
-          </a:p>
-          <a:p>
-            <a:pPr algn="l">
-              <a:buFont typeface="+mj-lt"/>
-              <a:buAutoNum type="arabicPeriod"/>
-            </a:pPr>
-            <a:r>
-              <a:rPr lang="en-US" b="1" i="0" u="none" strike="noStrike" dirty="0">
-                <a:solidFill>
-                  <a:srgbClr val="000000"/>
-                </a:solidFill>
-                <a:effectLst/>
-              </a:rPr>
-              <a:t>Training a Large Teacher Model</a:t>
-            </a:r>
-            <a:r>
-              <a:rPr lang="en-US" b="0" i="0" u="none" strike="noStrike" dirty="0">
-                <a:solidFill>
-                  <a:srgbClr val="000000"/>
-                </a:solidFill>
-                <a:effectLst/>
-              </a:rPr>
-              <a:t> – A large LLM is first pre-trained on vast amounts of data.</a:t>
-            </a:r>
-          </a:p>
-          <a:p>
-            <a:pPr algn="l">
-              <a:buFont typeface="+mj-lt"/>
-              <a:buAutoNum type="arabicPeriod"/>
-            </a:pPr>
-            <a:r>
-              <a:rPr lang="en-US" b="1" i="0" u="none" strike="noStrike" dirty="0">
-                <a:solidFill>
-                  <a:srgbClr val="000000"/>
-                </a:solidFill>
-                <a:effectLst/>
-              </a:rPr>
-              <a:t>Training a Smaller Student Model</a:t>
-            </a:r>
-            <a:r>
-              <a:rPr lang="en-US" b="0" i="0" u="none" strike="noStrike" dirty="0">
-                <a:solidFill>
-                  <a:srgbClr val="000000"/>
-                </a:solidFill>
-                <a:effectLst/>
-              </a:rPr>
-              <a:t> – Instead of training from scratch, the student model learns from the outputs (soft labels, logits, hidden representations) of the teacher model.</a:t>
-            </a:r>
-          </a:p>
-          <a:p>
-            <a:pPr algn="l">
-              <a:buFont typeface="+mj-lt"/>
-              <a:buAutoNum type="arabicPeriod"/>
-            </a:pPr>
-            <a:r>
-              <a:rPr lang="en-US" b="1" i="0" u="none" strike="noStrike" dirty="0">
-                <a:solidFill>
-                  <a:srgbClr val="000000"/>
-                </a:solidFill>
-                <a:effectLst/>
-              </a:rPr>
-              <a:t>Matching the Teacher’s Behavior</a:t>
-            </a:r>
-            <a:r>
-              <a:rPr lang="en-US" b="0" i="0" u="none" strike="noStrike" dirty="0">
-                <a:solidFill>
-                  <a:srgbClr val="000000"/>
-                </a:solidFill>
-                <a:effectLst/>
-              </a:rPr>
-              <a:t> – The student model optimizes its parameters to mimic the teacher model’s responses, probabilities, or intermediate representations.</a:t>
-            </a:r>
-          </a:p>
-          <a:p>
-            <a:pPr algn="l">
-              <a:buFont typeface="+mj-lt"/>
-              <a:buAutoNum type="arabicPeriod"/>
-            </a:pPr>
-            <a:r>
-              <a:rPr lang="en-US" b="1" i="0" u="none" strike="noStrike" dirty="0">
-                <a:solidFill>
-                  <a:srgbClr val="000000"/>
-                </a:solidFill>
-                <a:effectLst/>
-              </a:rPr>
-              <a:t>Fine-tuning for Specific Tasks</a:t>
-            </a:r>
-            <a:r>
-              <a:rPr lang="en-US" b="0" i="0" u="none" strike="noStrike" dirty="0">
-                <a:solidFill>
-                  <a:srgbClr val="000000"/>
-                </a:solidFill>
-                <a:effectLst/>
-              </a:rPr>
-              <a:t> – The student model is further fine-tuned to maintain high accuracy on key tasks while being much smaller and faster.</a:t>
-            </a:r>
-          </a:p>
-          <a:p>
-            <a:pPr marL="0" lvl="0" indent="0" algn="l">
-              <a:buFont typeface="+mj-lt"/>
-              <a:buNone/>
-            </a:pPr>
-            <a:endParaRPr lang="en-US" b="0" i="0" u="none" strike="noStrike" dirty="0">
-              <a:solidFill>
-                <a:srgbClr val="000000"/>
-              </a:solidFill>
-              <a:effectLst/>
-            </a:endParaRPr>
-          </a:p>
-          <a:p>
-            <a:endParaRPr lang="en-US" dirty="0"/>
-          </a:p>
-        </p:txBody>
-      </p:sp>
-      <p:sp>
-        <p:nvSpPr>
-          <p:cNvPr id="4" name="Slide Number Placeholder 3"/>
+        </p:txBody>
+      </p:sp>
+      <p:sp>
+        <p:nvSpPr>
+          <p:cNvPr id="4" name="Slide Number Placeholder 3">
+            <a:extLst>
+              <a:ext uri="{FF2B5EF4-FFF2-40B4-BE49-F238E27FC236}">
+                <a16:creationId xmlns:a16="http://schemas.microsoft.com/office/drawing/2014/main" id="{C627998B-9D26-742C-A9CD-4ECA23DC2525}"/>
+              </a:ext>
+            </a:extLst>
+          </p:cNvPr>
           <p:cNvSpPr>
             <a:spLocks noGrp="1"/>
           </p:cNvSpPr>
@@ -1286,7 +842,7 @@
           <a:p>
             <a:fld id="{7C803E4F-2807-8A41-95DA-1D03DD8A0194}" type="slidenum">
               <a:rPr lang="en-US" smtClean="0"/>
-              <a:t>7</a:t>
+              <a:t>5</a:t>
             </a:fld>
             <a:endParaRPr lang="en-US"/>
           </a:p>
@@ -1295,7 +851,7 @@
     </p:spTree>
     <p:extLst>
       <p:ext uri="{BB962C8B-B14F-4D97-AF65-F5344CB8AC3E}">
-        <p14:creationId xmlns:p14="http://schemas.microsoft.com/office/powerpoint/2010/main" val="294727998"/>
+        <p14:creationId xmlns:p14="http://schemas.microsoft.com/office/powerpoint/2010/main" val="3026046142"/>
       </p:ext>
     </p:extLst>
   </p:cSld>
@@ -1333,6 +889,13 @@
           </p:nvPr>
         </p:nvSpPr>
         <p:spPr/>
+        <p:txBody>
+          <a:bodyPr/>
+          <a:lstStyle/>
+          <a:p>
+            <a:endParaRPr lang="en-US"/>
+          </a:p>
+        </p:txBody>
       </p:sp>
       <p:sp>
         <p:nvSpPr>
@@ -1348,252 +911,6 @@
         <p:txBody>
           <a:bodyPr/>
           <a:lstStyle/>
-          <a:p>
-            <a:pPr algn="l"/>
-            <a:r>
-              <a:rPr lang="en-US" b="1" i="0" u="none" strike="noStrike" dirty="0">
-                <a:solidFill>
-                  <a:srgbClr val="000000"/>
-                </a:solidFill>
-                <a:effectLst/>
-              </a:rPr>
-              <a:t>Types of Quantization</a:t>
-            </a:r>
-          </a:p>
-          <a:p>
-            <a:pPr algn="l">
-              <a:buFont typeface="+mj-lt"/>
-              <a:buAutoNum type="arabicPeriod"/>
-            </a:pPr>
-            <a:r>
-              <a:rPr lang="en-US" b="1" i="0" u="none" strike="noStrike" dirty="0">
-                <a:solidFill>
-                  <a:srgbClr val="000000"/>
-                </a:solidFill>
-                <a:effectLst/>
-              </a:rPr>
-              <a:t>Post-Training Quantization (PTQ)</a:t>
-            </a:r>
-            <a:endParaRPr lang="en-US" b="0" i="0" u="none" strike="noStrike" dirty="0">
-              <a:solidFill>
-                <a:srgbClr val="000000"/>
-              </a:solidFill>
-              <a:effectLst/>
-            </a:endParaRPr>
-          </a:p>
-          <a:p>
-            <a:pPr marL="742950" lvl="1" indent="-285750" algn="l">
-              <a:buFont typeface="+mj-lt"/>
-              <a:buAutoNum type="arabicPeriod"/>
-            </a:pPr>
-            <a:r>
-              <a:rPr lang="en-US" b="0" i="0" u="none" strike="noStrike" dirty="0">
-                <a:solidFill>
-                  <a:srgbClr val="000000"/>
-                </a:solidFill>
-                <a:effectLst/>
-              </a:rPr>
-              <a:t>Applied after the model is trained.</a:t>
-            </a:r>
-          </a:p>
-          <a:p>
-            <a:pPr marL="742950" lvl="1" indent="-285750" algn="l">
-              <a:buFont typeface="+mj-lt"/>
-              <a:buAutoNum type="arabicPeriod"/>
-            </a:pPr>
-            <a:r>
-              <a:rPr lang="en-US" b="0" i="0" u="none" strike="noStrike" dirty="0">
-                <a:solidFill>
-                  <a:srgbClr val="000000"/>
-                </a:solidFill>
-                <a:effectLst/>
-              </a:rPr>
-              <a:t>Common in scenarios where retraining is expensive.</a:t>
-            </a:r>
-          </a:p>
-          <a:p>
-            <a:pPr marL="742950" lvl="1" indent="-285750" algn="l">
-              <a:buFont typeface="+mj-lt"/>
-              <a:buAutoNum type="arabicPeriod"/>
-            </a:pPr>
-            <a:r>
-              <a:rPr lang="en-US" b="0" i="0" u="none" strike="noStrike" dirty="0">
-                <a:solidFill>
-                  <a:srgbClr val="000000"/>
-                </a:solidFill>
-                <a:effectLst/>
-              </a:rPr>
-              <a:t>May lead to a slight accuracy drop but is widely used in deployment.</a:t>
-            </a:r>
-          </a:p>
-          <a:p>
-            <a:pPr algn="l">
-              <a:buFont typeface="+mj-lt"/>
-              <a:buAutoNum type="arabicPeriod"/>
-            </a:pPr>
-            <a:r>
-              <a:rPr lang="en-US" b="1" i="0" u="none" strike="noStrike" dirty="0">
-                <a:solidFill>
-                  <a:srgbClr val="000000"/>
-                </a:solidFill>
-                <a:effectLst/>
-              </a:rPr>
-              <a:t>Quantization-Aware Training (QAT)</a:t>
-            </a:r>
-            <a:endParaRPr lang="en-US" b="0" i="0" u="none" strike="noStrike" dirty="0">
-              <a:solidFill>
-                <a:srgbClr val="000000"/>
-              </a:solidFill>
-              <a:effectLst/>
-            </a:endParaRPr>
-          </a:p>
-          <a:p>
-            <a:pPr marL="742950" lvl="1" indent="-285750" algn="l">
-              <a:buFont typeface="+mj-lt"/>
-              <a:buAutoNum type="arabicPeriod"/>
-            </a:pPr>
-            <a:r>
-              <a:rPr lang="en-US" b="0" i="0" u="none" strike="noStrike" dirty="0">
-                <a:solidFill>
-                  <a:srgbClr val="000000"/>
-                </a:solidFill>
-                <a:effectLst/>
-              </a:rPr>
-              <a:t>Quantization is simulated during training so the model learns to adjust to lower precision.</a:t>
-            </a:r>
-          </a:p>
-          <a:p>
-            <a:pPr marL="742950" lvl="1" indent="-285750" algn="l">
-              <a:buFont typeface="+mj-lt"/>
-              <a:buAutoNum type="arabicPeriod"/>
-            </a:pPr>
-            <a:r>
-              <a:rPr lang="en-US" b="0" i="0" u="none" strike="noStrike" dirty="0">
-                <a:solidFill>
-                  <a:srgbClr val="000000"/>
-                </a:solidFill>
-                <a:effectLst/>
-              </a:rPr>
-              <a:t>More effective than PTQ in maintaining accuracy.</a:t>
-            </a:r>
-          </a:p>
-          <a:p>
-            <a:pPr marL="742950" lvl="1" indent="-285750" algn="l">
-              <a:buFont typeface="+mj-lt"/>
-              <a:buAutoNum type="arabicPeriod"/>
-            </a:pPr>
-            <a:r>
-              <a:rPr lang="en-US" b="0" i="0" u="none" strike="noStrike" dirty="0">
-                <a:solidFill>
-                  <a:srgbClr val="000000"/>
-                </a:solidFill>
-                <a:effectLst/>
-              </a:rPr>
-              <a:t>Requires more computational resources during training.</a:t>
-            </a:r>
-          </a:p>
-          <a:p>
-            <a:pPr algn="l">
-              <a:buFont typeface="+mj-lt"/>
-              <a:buAutoNum type="arabicPeriod"/>
-            </a:pPr>
-            <a:r>
-              <a:rPr lang="en-US" b="1" i="0" u="none" strike="noStrike" dirty="0">
-                <a:solidFill>
-                  <a:srgbClr val="000000"/>
-                </a:solidFill>
-                <a:effectLst/>
-              </a:rPr>
-              <a:t>Dynamic Quantization</a:t>
-            </a:r>
-            <a:endParaRPr lang="en-US" b="0" i="0" u="none" strike="noStrike" dirty="0">
-              <a:solidFill>
-                <a:srgbClr val="000000"/>
-              </a:solidFill>
-              <a:effectLst/>
-            </a:endParaRPr>
-          </a:p>
-          <a:p>
-            <a:pPr marL="742950" lvl="1" indent="-285750" algn="l">
-              <a:buFont typeface="+mj-lt"/>
-              <a:buAutoNum type="arabicPeriod"/>
-            </a:pPr>
-            <a:r>
-              <a:rPr lang="en-US" b="0" i="0" u="none" strike="noStrike" dirty="0">
-                <a:solidFill>
-                  <a:srgbClr val="000000"/>
-                </a:solidFill>
-                <a:effectLst/>
-              </a:rPr>
-              <a:t>Weights are quantized, but activations remain in full precision during inference.</a:t>
-            </a:r>
-          </a:p>
-          <a:p>
-            <a:pPr marL="742950" lvl="1" indent="-285750" algn="l">
-              <a:buFont typeface="+mj-lt"/>
-              <a:buAutoNum type="arabicPeriod"/>
-            </a:pPr>
-            <a:r>
-              <a:rPr lang="en-US" b="0" i="0" u="none" strike="noStrike" dirty="0">
-                <a:solidFill>
-                  <a:srgbClr val="000000"/>
-                </a:solidFill>
-                <a:effectLst/>
-              </a:rPr>
-              <a:t>Provides a balance between performance and accuracy.</a:t>
-            </a:r>
-          </a:p>
-          <a:p>
-            <a:pPr algn="l">
-              <a:buFont typeface="+mj-lt"/>
-              <a:buAutoNum type="arabicPeriod"/>
-            </a:pPr>
-            <a:r>
-              <a:rPr lang="en-US" b="1" i="0" u="none" strike="noStrike" dirty="0">
-                <a:solidFill>
-                  <a:srgbClr val="000000"/>
-                </a:solidFill>
-                <a:effectLst/>
-              </a:rPr>
-              <a:t>Mixed-Precision Quantization</a:t>
-            </a:r>
-            <a:endParaRPr lang="en-US" b="0" i="0" u="none" strike="noStrike" dirty="0">
-              <a:solidFill>
-                <a:srgbClr val="000000"/>
-              </a:solidFill>
-              <a:effectLst/>
-            </a:endParaRPr>
-          </a:p>
-          <a:p>
-            <a:pPr marL="742950" lvl="1" indent="-285750" algn="l">
-              <a:buFont typeface="+mj-lt"/>
-              <a:buAutoNum type="arabicPeriod"/>
-            </a:pPr>
-            <a:r>
-              <a:rPr lang="en-US" b="0" i="0" u="none" strike="noStrike" dirty="0">
-                <a:solidFill>
-                  <a:srgbClr val="000000"/>
-                </a:solidFill>
-                <a:effectLst/>
-              </a:rPr>
-              <a:t>Uses different bit precisions for different parts of the model (e.g., some layers in INT8, others in FP16).</a:t>
-            </a:r>
-          </a:p>
-          <a:p>
-            <a:pPr marL="742950" lvl="1" indent="-285750" algn="l">
-              <a:buFont typeface="+mj-lt"/>
-              <a:buAutoNum type="arabicPeriod"/>
-            </a:pPr>
-            <a:r>
-              <a:rPr lang="en-US" b="0" i="0" u="none" strike="noStrike" dirty="0">
-                <a:solidFill>
-                  <a:srgbClr val="000000"/>
-                </a:solidFill>
-                <a:effectLst/>
-              </a:rPr>
-              <a:t>Optimized for balancing efficiency and accuracy.</a:t>
-            </a:r>
-          </a:p>
           <a:p>
             <a:endParaRPr lang="en-US" dirty="0"/>
           </a:p>
@@ -1616,7 +933,7 @@
           <a:p>
             <a:fld id="{7C803E4F-2807-8A41-95DA-1D03DD8A0194}" type="slidenum">
               <a:rPr lang="en-US" smtClean="0"/>
-              <a:t>8</a:t>
+              <a:t>6</a:t>
             </a:fld>
             <a:endParaRPr lang="en-US"/>
           </a:p>
@@ -1625,7 +942,7 @@
     </p:spTree>
     <p:extLst>
       <p:ext uri="{BB962C8B-B14F-4D97-AF65-F5344CB8AC3E}">
-        <p14:creationId xmlns:p14="http://schemas.microsoft.com/office/powerpoint/2010/main" val="1253506263"/>
+        <p14:creationId xmlns:p14="http://schemas.microsoft.com/office/powerpoint/2010/main" val="4277700597"/>
       </p:ext>
     </p:extLst>
   </p:cSld>
@@ -1663,6 +980,13 @@
           </p:nvPr>
         </p:nvSpPr>
         <p:spPr/>
+        <p:txBody>
+          <a:bodyPr/>
+          <a:lstStyle/>
+          <a:p>
+            <a:endParaRPr lang="en-US"/>
+          </a:p>
+        </p:txBody>
       </p:sp>
       <p:sp>
         <p:nvSpPr>
@@ -1700,7 +1024,7 @@
           <a:p>
             <a:fld id="{7C803E4F-2807-8A41-95DA-1D03DD8A0194}" type="slidenum">
               <a:rPr lang="en-US" smtClean="0"/>
-              <a:t>9</a:t>
+              <a:t>7</a:t>
             </a:fld>
             <a:endParaRPr lang="en-US"/>
           </a:p>
@@ -1709,7 +1033,7 @@
     </p:spTree>
     <p:extLst>
       <p:ext uri="{BB962C8B-B14F-4D97-AF65-F5344CB8AC3E}">
-        <p14:creationId xmlns:p14="http://schemas.microsoft.com/office/powerpoint/2010/main" val="802086392"/>
+        <p14:creationId xmlns:p14="http://schemas.microsoft.com/office/powerpoint/2010/main" val="3388986232"/>
       </p:ext>
     </p:extLst>
   </p:cSld>
@@ -1747,6 +1071,327 @@
           </p:nvPr>
         </p:nvSpPr>
         <p:spPr/>
+      </p:sp>
+      <p:sp>
+        <p:nvSpPr>
+          <p:cNvPr id="3" name="Notes Placeholder 2"/>
+          <p:cNvSpPr>
+            <a:spLocks noGrp="1"/>
+          </p:cNvSpPr>
+          <p:nvPr>
+            <p:ph type="body" idx="1"/>
+          </p:nvPr>
+        </p:nvSpPr>
+        <p:spPr/>
+        <p:txBody>
+          <a:bodyPr/>
+          <a:lstStyle/>
+          <a:p>
+            <a:endParaRPr lang="en-US" dirty="0"/>
+          </a:p>
+        </p:txBody>
+      </p:sp>
+      <p:sp>
+        <p:nvSpPr>
+          <p:cNvPr id="4" name="Slide Number Placeholder 3"/>
+          <p:cNvSpPr>
+            <a:spLocks noGrp="1"/>
+          </p:cNvSpPr>
+          <p:nvPr>
+            <p:ph type="sldNum" sz="quarter" idx="5"/>
+          </p:nvPr>
+        </p:nvSpPr>
+        <p:spPr/>
+        <p:txBody>
+          <a:bodyPr/>
+          <a:lstStyle/>
+          <a:p>
+            <a:fld id="{7C803E4F-2807-8A41-95DA-1D03DD8A0194}" type="slidenum">
+              <a:rPr lang="en-US" smtClean="0"/>
+              <a:t>8</a:t>
+            </a:fld>
+            <a:endParaRPr lang="en-US"/>
+          </a:p>
+        </p:txBody>
+      </p:sp>
+    </p:spTree>
+    <p:extLst>
+      <p:ext uri="{BB962C8B-B14F-4D97-AF65-F5344CB8AC3E}">
+        <p14:creationId xmlns:p14="http://schemas.microsoft.com/office/powerpoint/2010/main" val="3750907478"/>
+      </p:ext>
+    </p:extLst>
+  </p:cSld>
+  <p:clrMapOvr>
+    <a:masterClrMapping/>
+  </p:clrMapOvr>
+</p:notes>
+</file>
+
+<file path=ppt/notesSlides/notesSlide8.xml><?xml version="1.0" encoding="utf-8"?>
+<p:notes xmlns:a="http://schemas.openxmlformats.org/drawingml/2006/main" xmlns:r="http://schemas.openxmlformats.org/officeDocument/2006/relationships" xmlns:p="http://schemas.openxmlformats.org/presentationml/2006/main">
+  <p:cSld>
+    <p:spTree>
+      <p:nvGrpSpPr>
+        <p:cNvPr id="1" name=""/>
+        <p:cNvGrpSpPr/>
+        <p:nvPr/>
+      </p:nvGrpSpPr>
+      <p:grpSpPr>
+        <a:xfrm>
+          <a:off x="0" y="0"/>
+          <a:ext cx="0" cy="0"/>
+          <a:chOff x="0" y="0"/>
+          <a:chExt cx="0" cy="0"/>
+        </a:xfrm>
+      </p:grpSpPr>
+      <p:sp>
+        <p:nvSpPr>
+          <p:cNvPr id="2" name="Slide Image Placeholder 1"/>
+          <p:cNvSpPr>
+            <a:spLocks noGrp="1" noRot="1" noChangeAspect="1"/>
+          </p:cNvSpPr>
+          <p:nvPr>
+            <p:ph type="sldImg"/>
+          </p:nvPr>
+        </p:nvSpPr>
+        <p:spPr/>
+        <p:txBody>
+          <a:bodyPr/>
+          <a:lstStyle/>
+          <a:p>
+            <a:endParaRPr lang="en-US"/>
+          </a:p>
+        </p:txBody>
+      </p:sp>
+      <p:sp>
+        <p:nvSpPr>
+          <p:cNvPr id="3" name="Notes Placeholder 2"/>
+          <p:cNvSpPr>
+            <a:spLocks noGrp="1"/>
+          </p:cNvSpPr>
+          <p:nvPr>
+            <p:ph type="body" idx="1"/>
+          </p:nvPr>
+        </p:nvSpPr>
+        <p:spPr/>
+        <p:txBody>
+          <a:bodyPr/>
+          <a:lstStyle/>
+          <a:p>
+            <a:r>
+              <a:rPr lang="en-US" b="0" i="0" u="none" strike="noStrike" dirty="0">
+                <a:solidFill>
+                  <a:srgbClr val="000000"/>
+                </a:solidFill>
+                <a:effectLst/>
+                <a:latin typeface="-webkit-standard"/>
+              </a:rPr>
+              <a:t>Quantization in LLMs is a technique used to reduce the memory footprint and computational cost of running large-scale neural networks by representing weights and activations with lower precision numerical formats (e.g., reducing from 32-bit floating point (FP32) to 8-bit integers (INT8) or lower).</a:t>
+            </a:r>
+          </a:p>
+          <a:p>
+            <a:endParaRPr lang="en-US" b="0" i="0" u="none" strike="noStrike" dirty="0">
+              <a:solidFill>
+                <a:srgbClr val="000000"/>
+              </a:solidFill>
+              <a:effectLst/>
+              <a:latin typeface="-webkit-standard"/>
+            </a:endParaRPr>
+          </a:p>
+          <a:p>
+            <a:r>
+              <a:rPr lang="en-US" b="0" i="0" u="none" strike="noStrike" dirty="0">
+                <a:solidFill>
+                  <a:srgbClr val="000000"/>
+                </a:solidFill>
+                <a:effectLst/>
+                <a:latin typeface="-webkit-standard"/>
+              </a:rPr>
+              <a:t>Quantization: </a:t>
+            </a:r>
+          </a:p>
+          <a:p>
+            <a:endParaRPr lang="en-US" b="0" i="0" u="none" strike="noStrike" dirty="0">
+              <a:solidFill>
+                <a:srgbClr val="000000"/>
+              </a:solidFill>
+              <a:effectLst/>
+              <a:latin typeface="-webkit-standard"/>
+            </a:endParaRPr>
+          </a:p>
+          <a:p>
+            <a:r>
+              <a:rPr lang="en-US" b="1" dirty="0"/>
+              <a:t>Reducing Model Size</a:t>
+            </a:r>
+            <a:r>
+              <a:rPr lang="en-US" dirty="0"/>
+              <a:t> – Uses less memory, allowing models to fit into smaller hardware (e.g., edge devices, consumer GPUs).</a:t>
+            </a:r>
+          </a:p>
+          <a:p>
+            <a:r>
+              <a:rPr lang="en-US" b="1" dirty="0"/>
+              <a:t>Speeding Up Inference</a:t>
+            </a:r>
+            <a:r>
+              <a:rPr lang="en-US" dirty="0"/>
+              <a:t> – Lower precision calculations are faster and consume less power.</a:t>
+            </a:r>
+          </a:p>
+          <a:p>
+            <a:r>
+              <a:rPr lang="en-US" b="1" dirty="0"/>
+              <a:t>Lowering Latency</a:t>
+            </a:r>
+            <a:r>
+              <a:rPr lang="en-US" dirty="0"/>
+              <a:t> – Essential for real-time applications like chatbots and AI assistants.</a:t>
+            </a:r>
+          </a:p>
+          <a:p>
+            <a:r>
+              <a:rPr lang="en-US" b="1" dirty="0"/>
+              <a:t>Reducing Energy Consumption</a:t>
+            </a:r>
+            <a:r>
+              <a:rPr lang="en-US" dirty="0"/>
+              <a:t> – Helps deploy AI models more efficiently on constrained hardware.</a:t>
+            </a:r>
+          </a:p>
+          <a:p>
+            <a:endParaRPr lang="en-US" dirty="0"/>
+          </a:p>
+          <a:p>
+            <a:pPr marL="285750" lvl="0" indent="-285750" algn="l">
+              <a:buFont typeface="+mj-lt"/>
+              <a:buAutoNum type="arabicPeriod"/>
+            </a:pPr>
+            <a:endParaRPr lang="en-US" b="0" i="0" u="none" strike="noStrike" dirty="0">
+              <a:solidFill>
+                <a:srgbClr val="000000"/>
+              </a:solidFill>
+              <a:effectLst/>
+            </a:endParaRPr>
+          </a:p>
+          <a:p>
+            <a:pPr algn="l"/>
+            <a:r>
+              <a:rPr lang="en-US" b="0" i="0" u="none" strike="noStrike" dirty="0">
+                <a:solidFill>
+                  <a:srgbClr val="000000"/>
+                </a:solidFill>
+                <a:effectLst/>
+              </a:rPr>
+              <a:t>Distillation in Large Language Models (LLMs) refers to a </a:t>
+            </a:r>
+            <a:r>
+              <a:rPr lang="en-US" b="1" i="0" u="none" strike="noStrike" dirty="0">
+                <a:solidFill>
+                  <a:srgbClr val="000000"/>
+                </a:solidFill>
+                <a:effectLst/>
+              </a:rPr>
+              <a:t>knowledge transfer technique</a:t>
+            </a:r>
+            <a:r>
+              <a:rPr lang="en-US" b="0" i="0" u="none" strike="noStrike" dirty="0">
+                <a:solidFill>
+                  <a:srgbClr val="000000"/>
+                </a:solidFill>
+                <a:effectLst/>
+              </a:rPr>
+              <a:t> where a smaller, more efficient model (student model) learns from a larger, more powerful model (teacher model). This process helps compress the knowledge of the large model into a smaller one while maintaining performance.</a:t>
+            </a:r>
+          </a:p>
+          <a:p>
+            <a:pPr marL="0" lvl="0" indent="0" algn="l">
+              <a:buFont typeface="+mj-lt"/>
+              <a:buNone/>
+            </a:pPr>
+            <a:endParaRPr lang="en-US" b="0" i="0" u="none" strike="noStrike" dirty="0">
+              <a:solidFill>
+                <a:srgbClr val="000000"/>
+              </a:solidFill>
+              <a:effectLst/>
+            </a:endParaRPr>
+          </a:p>
+          <a:p>
+            <a:endParaRPr lang="en-US" dirty="0"/>
+          </a:p>
+        </p:txBody>
+      </p:sp>
+      <p:sp>
+        <p:nvSpPr>
+          <p:cNvPr id="4" name="Slide Number Placeholder 3"/>
+          <p:cNvSpPr>
+            <a:spLocks noGrp="1"/>
+          </p:cNvSpPr>
+          <p:nvPr>
+            <p:ph type="sldNum" sz="quarter" idx="5"/>
+          </p:nvPr>
+        </p:nvSpPr>
+        <p:spPr/>
+        <p:txBody>
+          <a:bodyPr/>
+          <a:lstStyle/>
+          <a:p>
+            <a:fld id="{7C803E4F-2807-8A41-95DA-1D03DD8A0194}" type="slidenum">
+              <a:rPr lang="en-US" smtClean="0"/>
+              <a:t>9</a:t>
+            </a:fld>
+            <a:endParaRPr lang="en-US"/>
+          </a:p>
+        </p:txBody>
+      </p:sp>
+    </p:spTree>
+    <p:extLst>
+      <p:ext uri="{BB962C8B-B14F-4D97-AF65-F5344CB8AC3E}">
+        <p14:creationId xmlns:p14="http://schemas.microsoft.com/office/powerpoint/2010/main" val="294727998"/>
+      </p:ext>
+    </p:extLst>
+  </p:cSld>
+  <p:clrMapOvr>
+    <a:masterClrMapping/>
+  </p:clrMapOvr>
+</p:notes>
+</file>
+
+<file path=ppt/notesSlides/notesSlide9.xml><?xml version="1.0" encoding="utf-8"?>
+<p:notes xmlns:a="http://schemas.openxmlformats.org/drawingml/2006/main" xmlns:r="http://schemas.openxmlformats.org/officeDocument/2006/relationships" xmlns:p="http://schemas.openxmlformats.org/presentationml/2006/main">
+  <p:cSld>
+    <p:spTree>
+      <p:nvGrpSpPr>
+        <p:cNvPr id="1" name=""/>
+        <p:cNvGrpSpPr/>
+        <p:nvPr/>
+      </p:nvGrpSpPr>
+      <p:grpSpPr>
+        <a:xfrm>
+          <a:off x="0" y="0"/>
+          <a:ext cx="0" cy="0"/>
+          <a:chOff x="0" y="0"/>
+          <a:chExt cx="0" cy="0"/>
+        </a:xfrm>
+      </p:grpSpPr>
+      <p:sp>
+        <p:nvSpPr>
+          <p:cNvPr id="2" name="Slide Image Placeholder 1"/>
+          <p:cNvSpPr>
+            <a:spLocks noGrp="1" noRot="1" noChangeAspect="1"/>
+          </p:cNvSpPr>
+          <p:nvPr>
+            <p:ph type="sldImg"/>
+          </p:nvPr>
+        </p:nvSpPr>
+        <p:spPr/>
+        <p:txBody>
+          <a:bodyPr/>
+          <a:lstStyle/>
+          <a:p>
+            <a:endParaRPr lang="en-US"/>
+          </a:p>
+        </p:txBody>
       </p:sp>
       <p:sp>
         <p:nvSpPr>
@@ -1950,7 +1595,7 @@
           <a:p>
             <a:fld id="{073D55F9-11A3-4523-8F38-6BA37933791A}" type="datetime1">
               <a:rPr lang="en-US" smtClean="0"/>
-              <a:t>5/7/25</a:t>
+              <a:t>5/5/26</a:t>
             </a:fld>
             <a:endParaRPr lang="en-US"/>
           </a:p>
@@ -2151,7 +1796,7 @@
           <a:p>
             <a:fld id="{0B4E757A-3EC2-4683-9080-1A460C37C843}" type="datetime1">
               <a:rPr lang="en-US" smtClean="0"/>
-              <a:t>5/7/25</a:t>
+              <a:t>5/5/26</a:t>
             </a:fld>
             <a:endParaRPr lang="en-US"/>
           </a:p>
@@ -2362,7 +2007,7 @@
           <a:p>
             <a:fld id="{5CC8096C-64ED-4153-A483-5C02E44AD5C3}" type="datetime1">
               <a:rPr lang="en-US" smtClean="0"/>
-              <a:t>5/7/25</a:t>
+              <a:t>5/5/26</a:t>
             </a:fld>
             <a:endParaRPr lang="en-US" dirty="0"/>
           </a:p>
@@ -2563,7 +2208,7 @@
           <a:p>
             <a:fld id="{1CB9D56B-6EBE-4E5F-99D9-2A3DBDF37D0A}" type="datetime1">
               <a:rPr lang="en-US" smtClean="0"/>
-              <a:t>5/7/25</a:t>
+              <a:t>5/5/26</a:t>
             </a:fld>
             <a:endParaRPr lang="en-US"/>
           </a:p>
@@ -2841,7 +2486,7 @@
           <a:p>
             <a:fld id="{8C33F3CA-C7E3-432D-9282-18F13836509A}" type="datetime1">
               <a:rPr lang="en-US" smtClean="0"/>
-              <a:t>5/7/25</a:t>
+              <a:t>5/5/26</a:t>
             </a:fld>
             <a:endParaRPr lang="en-US" dirty="0"/>
           </a:p>
@@ -3109,7 +2754,7 @@
           <a:p>
             <a:fld id="{75BE9C62-1337-40B8-BA50-E9F4861DB4BC}" type="datetime1">
               <a:rPr lang="en-US" smtClean="0"/>
-              <a:t>5/7/25</a:t>
+              <a:t>5/5/26</a:t>
             </a:fld>
             <a:endParaRPr lang="en-US"/>
           </a:p>
@@ -3524,7 +3169,7 @@
           <a:p>
             <a:fld id="{47C195EB-2DA3-4B24-8725-19BC22A7BE50}" type="datetime1">
               <a:rPr lang="en-US" smtClean="0"/>
-              <a:t>5/7/25</a:t>
+              <a:t>5/5/26</a:t>
             </a:fld>
             <a:endParaRPr lang="en-US"/>
           </a:p>
@@ -3668,7 +3313,7 @@
           <a:p>
             <a:fld id="{F4E237E6-0076-4915-A5A8-B7C11FA4F374}" type="datetime1">
               <a:rPr lang="en-US" smtClean="0"/>
-              <a:t>5/7/25</a:t>
+              <a:t>5/5/26</a:t>
             </a:fld>
             <a:endParaRPr lang="en-US"/>
           </a:p>
@@ -3784,7 +3429,7 @@
           <a:p>
             <a:fld id="{3505F58F-C0B5-422A-8E5A-6B99E5D80F0A}" type="datetime1">
               <a:rPr lang="en-US" smtClean="0"/>
-              <a:t>5/7/25</a:t>
+              <a:t>5/5/26</a:t>
             </a:fld>
             <a:endParaRPr lang="en-US"/>
           </a:p>
@@ -4098,7 +3743,7 @@
           <a:p>
             <a:fld id="{7565E655-9687-48DF-A33F-F8824CCCB5D1}" type="datetime1">
               <a:rPr lang="en-US" smtClean="0"/>
-              <a:t>5/7/25</a:t>
+              <a:t>5/5/26</a:t>
             </a:fld>
             <a:endParaRPr lang="en-US"/>
           </a:p>
@@ -4389,7 +4034,7 @@
           <a:p>
             <a:fld id="{B97FD56A-AAB8-4544-A495-D0645413C9E3}" type="datetime1">
               <a:rPr lang="en-US" smtClean="0"/>
-              <a:t>5/7/25</a:t>
+              <a:t>5/5/26</a:t>
             </a:fld>
             <a:endParaRPr lang="en-US"/>
           </a:p>
@@ -4634,7 +4279,7 @@
             <a:fld id="{193BAB95-8DA7-460B-B00A-7037C8394FB0}" type="datetime1">
               <a:rPr lang="en-US" smtClean="0"/>
               <a:pPr/>
-              <a:t>5/7/25</a:t>
+              <a:t>5/5/26</a:t>
             </a:fld>
             <a:endParaRPr lang="en-US" dirty="0"/>
           </a:p>
@@ -5715,28 +5360,6 @@
           </a:bodyPr>
           <a:lstStyle/>
           <a:p>
-            <a:r>
-              <a:rPr lang="en-US" dirty="0" err="1"/>
-              <a:t>HuggingFace</a:t>
-            </a:r>
-            <a:r>
-              <a:rPr lang="en-US" dirty="0"/>
-              <a:t> – programmatic approach for inference and training</a:t>
-            </a:r>
-          </a:p>
-          <a:p>
-            <a:pPr lvl="1"/>
-            <a:r>
-              <a:rPr lang="en-US" dirty="0"/>
-              <a:t>Run locally/</a:t>
-            </a:r>
-            <a:r>
-              <a:rPr lang="en-US" dirty="0" err="1"/>
-              <a:t>Colab</a:t>
-            </a:r>
-            <a:endParaRPr lang="en-US" dirty="0"/>
-          </a:p>
-          <a:p>
             <a:pPr lvl="1"/>
             <a:endParaRPr lang="en-US" dirty="0"/>
           </a:p>
@@ -5752,16 +5375,6 @@
           </a:p>
           <a:p>
             <a:endParaRPr lang="en-US" dirty="0"/>
-          </a:p>
-          <a:p>
-            <a:r>
-              <a:rPr lang="en-US" dirty="0" err="1"/>
-              <a:t>Ollama</a:t>
-            </a:r>
-            <a:r>
-              <a:rPr lang="en-US" dirty="0"/>
-              <a:t> – Command Line Inferencing</a:t>
-            </a:r>
           </a:p>
         </p:txBody>
       </p:sp>
@@ -5855,33 +5468,16 @@
           <a:p>
             <a:r>
               <a:rPr lang="en-US" dirty="0"/>
-              <a:t>Running, Training and Hosting local models</a:t>
-            </a:r>
-          </a:p>
-          <a:p>
-            <a:pPr lvl="1"/>
-            <a:r>
-              <a:rPr lang="en-US" dirty="0" err="1"/>
-              <a:t>HuggingFace</a:t>
-            </a:r>
+              <a:t>Working Locally</a:t>
+            </a:r>
+          </a:p>
+          <a:p>
             <a:endParaRPr lang="en-US" dirty="0"/>
           </a:p>
           <a:p>
-            <a:pPr lvl="1"/>
             <a:r>
               <a:rPr lang="en-US" dirty="0"/>
-              <a:t>LM Studio (Apple Silicon Macs, Windows, Linux)</a:t>
-            </a:r>
-          </a:p>
-          <a:p>
-            <a:pPr lvl="1"/>
-            <a:r>
-              <a:rPr lang="en-US" dirty="0" err="1"/>
-              <a:t>Ollama</a:t>
-            </a:r>
-            <a:r>
-              <a:rPr lang="en-US" dirty="0"/>
-              <a:t> (Mac, Windows, Linux)</a:t>
+              <a:t>Introduction to Claude, Claude Cowork and Claude Code</a:t>
             </a:r>
           </a:p>
         </p:txBody>
@@ -5939,7 +5535,7 @@
           <a:p>
             <a:r>
               <a:rPr lang="en-US" dirty="0"/>
-              <a:t>Downloads </a:t>
+              <a:t>Optional Download for working Locally</a:t>
             </a:r>
           </a:p>
         </p:txBody>
@@ -5979,35 +5575,15 @@
           </a:p>
           <a:p>
             <a:r>
-              <a:rPr lang="en-US" dirty="0" err="1"/>
-              <a:t>Ollama</a:t>
-            </a:r>
-            <a:r>
               <a:rPr lang="en-US" dirty="0"/>
-              <a:t> - </a:t>
+              <a:t>OpenCode - </a:t>
             </a:r>
             <a:r>
               <a:rPr lang="en-US" dirty="0">
                 <a:hlinkClick r:id="rId4"/>
               </a:rPr>
-              <a:t>https://ollama.com</a:t>
-            </a:r>
-            <a:endParaRPr lang="en-US" dirty="0"/>
-          </a:p>
-          <a:p>
-            <a:r>
-              <a:rPr lang="en-US" dirty="0"/>
-              <a:t>Hugging Face API Key - </a:t>
-            </a:r>
-            <a:r>
-              <a:rPr lang="en-US" dirty="0">
-                <a:hlinkClick r:id="rId5"/>
-              </a:rPr>
-              <a:t>https://huggingface.co/settings/profile</a:t>
-            </a:r>
-            <a:endParaRPr lang="en-US" dirty="0"/>
-          </a:p>
-          <a:p>
+              <a:t>https://opencode.ai</a:t>
+            </a:r>
             <a:endParaRPr lang="en-US" dirty="0"/>
           </a:p>
         </p:txBody>
@@ -6100,7 +5676,7 @@
           <p:nvPr/>
         </p:nvPicPr>
         <p:blipFill rotWithShape="1">
-          <a:blip r:embed="rId2"/>
+          <a:blip r:embed="rId3"/>
           <a:srcRect l="13254" r="36608" b="-1"/>
           <a:stretch/>
         </p:blipFill>
@@ -6184,8 +5760,8 @@
         </p:nvSpPr>
         <p:spPr>
           <a:xfrm>
-            <a:off x="5868557" y="2551176"/>
-            <a:ext cx="5444382" cy="3591207"/>
+            <a:off x="5868557" y="2000251"/>
+            <a:ext cx="5444382" cy="4857749"/>
           </a:xfrm>
         </p:spPr>
         <p:txBody>
@@ -6195,44 +5771,51 @@
           <a:lstStyle/>
           <a:p>
             <a:r>
-              <a:rPr lang="en-US" sz="2000" dirty="0"/>
-              <a:t>By default, conversations with ChatGPT may be used for future training</a:t>
-            </a:r>
-          </a:p>
-          <a:p>
-            <a:r>
-              <a:rPr lang="en-US" sz="2000" dirty="0"/>
+              <a:rPr lang="en-US" sz="2400" dirty="0"/>
+              <a:t>By default, conversations with ChatGPT, Claude, Gemini or most LLMs provided through an online service may be used for future training</a:t>
+            </a:r>
+          </a:p>
+          <a:p>
+            <a:r>
+              <a:rPr lang="en-US" sz="2400" dirty="0"/>
               <a:t>Any requests through the API to chat models and embedding models may also be used to train new models</a:t>
             </a:r>
           </a:p>
           <a:p>
             <a:r>
-              <a:rPr lang="en-US" sz="2000" dirty="0"/>
+              <a:rPr lang="en-US" sz="2400" dirty="0"/>
               <a:t>When working with secure data, alternate approaches are required</a:t>
             </a:r>
           </a:p>
           <a:p>
             <a:pPr lvl="1"/>
             <a:r>
-              <a:rPr lang="en-US" sz="2000" dirty="0"/>
+              <a:rPr lang="en-US" dirty="0"/>
               <a:t>Enterprise contracts</a:t>
             </a:r>
           </a:p>
           <a:p>
             <a:pPr lvl="1"/>
             <a:r>
-              <a:rPr lang="en-US" sz="2000" dirty="0"/>
+              <a:rPr lang="en-US" dirty="0"/>
               <a:t>Open-source models</a:t>
+            </a:r>
+          </a:p>
+          <a:p>
+            <a:pPr lvl="1"/>
+            <a:r>
+              <a:rPr lang="en-US" dirty="0"/>
+              <a:t>Custom Solutions</a:t>
             </a:r>
           </a:p>
           <a:p>
             <a:pPr marL="0" indent="0">
               <a:buNone/>
             </a:pPr>
-            <a:endParaRPr lang="en-US" sz="2000" dirty="0"/>
-          </a:p>
-          <a:p>
-            <a:endParaRPr lang="en-US" sz="2000" dirty="0"/>
+            <a:endParaRPr lang="en-US" sz="2400" dirty="0"/>
+          </a:p>
+          <a:p>
+            <a:endParaRPr lang="en-US" sz="2400" dirty="0"/>
           </a:p>
         </p:txBody>
       </p:sp>
@@ -6250,6 +5833,329 @@
 </file>
 
 <file path=ppt/slides/slide5.xml><?xml version="1.0" encoding="utf-8"?>
+<p:sld xmlns:a="http://schemas.openxmlformats.org/drawingml/2006/main" xmlns:r="http://schemas.openxmlformats.org/officeDocument/2006/relationships" xmlns:p="http://schemas.openxmlformats.org/presentationml/2006/main">
+  <p:cSld>
+    <p:bg>
+      <p:bgPr>
+        <a:solidFill>
+          <a:schemeClr val="bg1"/>
+        </a:solidFill>
+        <a:effectLst/>
+      </p:bgPr>
+    </p:bg>
+    <p:spTree>
+      <p:nvGrpSpPr>
+        <p:cNvPr id="1" name="">
+          <a:extLst>
+            <a:ext uri="{FF2B5EF4-FFF2-40B4-BE49-F238E27FC236}">
+              <a16:creationId xmlns:a16="http://schemas.microsoft.com/office/drawing/2014/main" id="{D144FD14-8BD6-23F3-371A-DD91220637EF}"/>
+            </a:ext>
+          </a:extLst>
+        </p:cNvPr>
+        <p:cNvGrpSpPr/>
+        <p:nvPr/>
+      </p:nvGrpSpPr>
+      <p:grpSpPr>
+        <a:xfrm>
+          <a:off x="0" y="0"/>
+          <a:ext cx="0" cy="0"/>
+          <a:chOff x="0" y="0"/>
+          <a:chExt cx="0" cy="0"/>
+        </a:xfrm>
+      </p:grpSpPr>
+      <p:sp useBgFill="1">
+        <p:nvSpPr>
+          <p:cNvPr id="27" name="Rectangle 26">
+            <a:extLst>
+              <a:ext uri="{FF2B5EF4-FFF2-40B4-BE49-F238E27FC236}">
+                <a16:creationId xmlns:a16="http://schemas.microsoft.com/office/drawing/2014/main" id="{081EA652-8C6A-4E69-BEB9-170809474553}"/>
+              </a:ext>
+              <a:ext uri="{C183D7F6-B498-43B3-948B-1728B52AA6E4}">
+                <adec:decorative xmlns:adec="http://schemas.microsoft.com/office/drawing/2017/decorative" val="1"/>
+              </a:ext>
+            </a:extLst>
+          </p:cNvPr>
+          <p:cNvSpPr>
+            <a:spLocks noGrp="1" noRot="1" noChangeAspect="1" noMove="1" noResize="1" noEditPoints="1" noAdjustHandles="1" noChangeArrowheads="1" noChangeShapeType="1" noTextEdit="1"/>
+          </p:cNvSpPr>
+          <p:nvPr>
+            <p:extLst>
+              <p:ext uri="{386F3935-93C4-4BCD-93E2-E3B085C9AB24}">
+                <p16:designElem xmlns:p16="http://schemas.microsoft.com/office/powerpoint/2015/main" val="1"/>
+              </p:ext>
+            </p:extLst>
+          </p:nvPr>
+        </p:nvSpPr>
+        <p:spPr>
+          <a:xfrm>
+            <a:off x="0" y="0"/>
+            <a:ext cx="12192000" cy="6858000"/>
+          </a:xfrm>
+          <a:prstGeom prst="rect">
+            <a:avLst/>
+          </a:prstGeom>
+          <a:ln>
+            <a:noFill/>
+          </a:ln>
+        </p:spPr>
+        <p:style>
+          <a:lnRef idx="2">
+            <a:schemeClr val="accent1">
+              <a:shade val="50000"/>
+            </a:schemeClr>
+          </a:lnRef>
+          <a:fillRef idx="1">
+            <a:schemeClr val="accent1"/>
+          </a:fillRef>
+          <a:effectRef idx="0">
+            <a:schemeClr val="accent1"/>
+          </a:effectRef>
+          <a:fontRef idx="minor">
+            <a:schemeClr val="lt1"/>
+          </a:fontRef>
+        </p:style>
+        <p:txBody>
+          <a:bodyPr rtlCol="0" anchor="ctr"/>
+          <a:lstStyle/>
+          <a:p>
+            <a:pPr algn="ctr"/>
+            <a:endParaRPr lang="en-US"/>
+          </a:p>
+        </p:txBody>
+      </p:sp>
+      <p:sp>
+        <p:nvSpPr>
+          <p:cNvPr id="28" name="Right Triangle 27">
+            <a:extLst>
+              <a:ext uri="{FF2B5EF4-FFF2-40B4-BE49-F238E27FC236}">
+                <a16:creationId xmlns:a16="http://schemas.microsoft.com/office/drawing/2014/main" id="{5298780A-33B9-4EA2-8F67-DE68AD62841B}"/>
+              </a:ext>
+              <a:ext uri="{C183D7F6-B498-43B3-948B-1728B52AA6E4}">
+                <adec:decorative xmlns:adec="http://schemas.microsoft.com/office/drawing/2017/decorative" val="1"/>
+              </a:ext>
+            </a:extLst>
+          </p:cNvPr>
+          <p:cNvSpPr>
+            <a:spLocks noGrp="1" noRot="1" noChangeAspect="1" noMove="1" noResize="1" noEditPoints="1" noAdjustHandles="1" noChangeArrowheads="1" noChangeShapeType="1" noTextEdit="1"/>
+          </p:cNvSpPr>
+          <p:nvPr>
+            <p:extLst>
+              <p:ext uri="{386F3935-93C4-4BCD-93E2-E3B085C9AB24}">
+                <p16:designElem xmlns:p16="http://schemas.microsoft.com/office/powerpoint/2015/main" val="1"/>
+              </p:ext>
+            </p:extLst>
+          </p:nvPr>
+        </p:nvSpPr>
+        <p:spPr>
+          <a:xfrm flipH="1">
+            <a:off x="8576720" y="3335867"/>
+            <a:ext cx="3291840" cy="3200400"/>
+          </a:xfrm>
+          <a:prstGeom prst="rtTriangle">
+            <a:avLst/>
+          </a:prstGeom>
+          <a:solidFill>
+            <a:schemeClr val="accent4"/>
+          </a:solidFill>
+          <a:ln>
+            <a:noFill/>
+          </a:ln>
+        </p:spPr>
+        <p:style>
+          <a:lnRef idx="2">
+            <a:schemeClr val="accent1">
+              <a:shade val="50000"/>
+            </a:schemeClr>
+          </a:lnRef>
+          <a:fillRef idx="1">
+            <a:schemeClr val="accent1"/>
+          </a:fillRef>
+          <a:effectRef idx="0">
+            <a:schemeClr val="accent1"/>
+          </a:effectRef>
+          <a:fontRef idx="minor">
+            <a:schemeClr val="lt1"/>
+          </a:fontRef>
+        </p:style>
+        <p:txBody>
+          <a:bodyPr rtlCol="0" anchor="ctr"/>
+          <a:lstStyle/>
+          <a:p>
+            <a:pPr algn="ctr"/>
+            <a:endParaRPr lang="en-US" dirty="0"/>
+          </a:p>
+        </p:txBody>
+      </p:sp>
+      <p:sp>
+        <p:nvSpPr>
+          <p:cNvPr id="29" name="Rectangle 28">
+            <a:extLst>
+              <a:ext uri="{FF2B5EF4-FFF2-40B4-BE49-F238E27FC236}">
+                <a16:creationId xmlns:a16="http://schemas.microsoft.com/office/drawing/2014/main" id="{7F488E8B-4E1E-4402-8935-D4E6C02615C7}"/>
+              </a:ext>
+              <a:ext uri="{C183D7F6-B498-43B3-948B-1728B52AA6E4}">
+                <adec:decorative xmlns:adec="http://schemas.microsoft.com/office/drawing/2017/decorative" val="1"/>
+              </a:ext>
+            </a:extLst>
+          </p:cNvPr>
+          <p:cNvSpPr>
+            <a:spLocks noGrp="1" noRot="1" noChangeAspect="1" noMove="1" noResize="1" noEditPoints="1" noAdjustHandles="1" noChangeArrowheads="1" noChangeShapeType="1" noTextEdit="1"/>
+          </p:cNvSpPr>
+          <p:nvPr>
+            <p:extLst>
+              <p:ext uri="{386F3935-93C4-4BCD-93E2-E3B085C9AB24}">
+                <p16:designElem xmlns:p16="http://schemas.microsoft.com/office/powerpoint/2015/main" val="1"/>
+              </p:ext>
+            </p:extLst>
+          </p:nvPr>
+        </p:nvSpPr>
+        <p:spPr>
+          <a:xfrm>
+            <a:off x="641774" y="623275"/>
+            <a:ext cx="10905053" cy="5607882"/>
+          </a:xfrm>
+          <a:prstGeom prst="rect">
+            <a:avLst/>
+          </a:prstGeom>
+          <a:noFill/>
+          <a:ln w="19050">
+            <a:solidFill>
+              <a:schemeClr val="tx1">
+                <a:lumMod val="75000"/>
+                <a:lumOff val="25000"/>
+              </a:schemeClr>
+            </a:solidFill>
+          </a:ln>
+        </p:spPr>
+        <p:style>
+          <a:lnRef idx="2">
+            <a:schemeClr val="accent1">
+              <a:shade val="50000"/>
+            </a:schemeClr>
+          </a:lnRef>
+          <a:fillRef idx="1">
+            <a:schemeClr val="accent1"/>
+          </a:fillRef>
+          <a:effectRef idx="0">
+            <a:schemeClr val="accent1"/>
+          </a:effectRef>
+          <a:fontRef idx="minor">
+            <a:schemeClr val="lt1"/>
+          </a:fontRef>
+        </p:style>
+        <p:txBody>
+          <a:bodyPr rtlCol="0" anchor="ctr"/>
+          <a:lstStyle/>
+          <a:p>
+            <a:pPr algn="ctr"/>
+            <a:endParaRPr lang="en-US"/>
+          </a:p>
+        </p:txBody>
+      </p:sp>
+      <p:sp>
+        <p:nvSpPr>
+          <p:cNvPr id="4" name="Title 3">
+            <a:extLst>
+              <a:ext uri="{FF2B5EF4-FFF2-40B4-BE49-F238E27FC236}">
+                <a16:creationId xmlns:a16="http://schemas.microsoft.com/office/drawing/2014/main" id="{F08FB72E-67BB-E934-A9AF-CDB919220A0E}"/>
+              </a:ext>
+            </a:extLst>
+          </p:cNvPr>
+          <p:cNvSpPr>
+            <a:spLocks noGrp="1"/>
+          </p:cNvSpPr>
+          <p:nvPr>
+            <p:ph type="title"/>
+          </p:nvPr>
+        </p:nvSpPr>
+        <p:spPr>
+          <a:xfrm>
+            <a:off x="1285240" y="1050595"/>
+            <a:ext cx="8074815" cy="1618489"/>
+          </a:xfrm>
+        </p:spPr>
+        <p:txBody>
+          <a:bodyPr anchor="ctr">
+            <a:normAutofit/>
+          </a:bodyPr>
+          <a:lstStyle/>
+          <a:p>
+            <a:r>
+              <a:rPr lang="en-US" sz="5000"/>
+              <a:t>How do enterprise contracts work?</a:t>
+            </a:r>
+          </a:p>
+        </p:txBody>
+      </p:sp>
+      <p:sp>
+        <p:nvSpPr>
+          <p:cNvPr id="8" name="Content Placeholder 7">
+            <a:extLst>
+              <a:ext uri="{FF2B5EF4-FFF2-40B4-BE49-F238E27FC236}">
+                <a16:creationId xmlns:a16="http://schemas.microsoft.com/office/drawing/2014/main" id="{F5AC8253-7D0C-6358-F7B8-57A9ED09A218}"/>
+              </a:ext>
+            </a:extLst>
+          </p:cNvPr>
+          <p:cNvSpPr>
+            <a:spLocks noGrp="1"/>
+          </p:cNvSpPr>
+          <p:nvPr>
+            <p:ph idx="1"/>
+          </p:nvPr>
+        </p:nvSpPr>
+        <p:spPr>
+          <a:xfrm>
+            <a:off x="1285240" y="2969469"/>
+            <a:ext cx="8074815" cy="2800395"/>
+          </a:xfrm>
+        </p:spPr>
+        <p:txBody>
+          <a:bodyPr anchor="t">
+            <a:normAutofit/>
+          </a:bodyPr>
+          <a:lstStyle/>
+          <a:p>
+            <a:r>
+              <a:rPr lang="en-US" sz="2400"/>
+              <a:t>LLMs aren’t always learning – providers collect training data over time and use our conversations to further train their models</a:t>
+            </a:r>
+          </a:p>
+          <a:p>
+            <a:r>
+              <a:rPr lang="en-US" sz="2400"/>
+              <a:t>Under certain paid plans and agreements, you can opt out of your data being used for training – </a:t>
+            </a:r>
+            <a:r>
+              <a:rPr lang="en-US" sz="2400" b="1"/>
+              <a:t>Note: </a:t>
+            </a:r>
+            <a:r>
+              <a:rPr lang="en-US" sz="2400"/>
+              <a:t>You must manually enable this – a paid plan does not automatically opt you out of training</a:t>
+            </a:r>
+          </a:p>
+          <a:p>
+            <a:endParaRPr lang="en-US" sz="2400"/>
+          </a:p>
+          <a:p>
+            <a:endParaRPr lang="en-US" sz="2400"/>
+          </a:p>
+        </p:txBody>
+      </p:sp>
+    </p:spTree>
+    <p:extLst>
+      <p:ext uri="{BB962C8B-B14F-4D97-AF65-F5344CB8AC3E}">
+        <p14:creationId xmlns:p14="http://schemas.microsoft.com/office/powerpoint/2010/main" val="1525328125"/>
+      </p:ext>
+    </p:extLst>
+  </p:cSld>
+  <p:clrMapOvr>
+    <a:masterClrMapping/>
+  </p:clrMapOvr>
+</p:sld>
+</file>
+
+<file path=ppt/slides/slide6.xml><?xml version="1.0" encoding="utf-8"?>
 <p:sld xmlns:a="http://schemas.openxmlformats.org/drawingml/2006/main" xmlns:r="http://schemas.openxmlformats.org/officeDocument/2006/relationships" xmlns:p="http://schemas.openxmlformats.org/presentationml/2006/main">
   <p:cSld>
     <p:bg>
@@ -7230,7 +7136,7 @@
 </p:sld>
 </file>
 
-<file path=ppt/slides/slide6.xml><?xml version="1.0" encoding="utf-8"?>
+<file path=ppt/slides/slide7.xml><?xml version="1.0" encoding="utf-8"?>
 <p:sld xmlns:a="http://schemas.openxmlformats.org/drawingml/2006/main" xmlns:r="http://schemas.openxmlformats.org/officeDocument/2006/relationships" xmlns:p="http://schemas.openxmlformats.org/presentationml/2006/main">
   <p:cSld>
     <p:spTree>
@@ -7263,7 +7169,7 @@
             <p:ph idx="1"/>
             <p:extLst>
               <p:ext uri="{D42A27DB-BD31-4B8C-83A1-F6EECF244321}">
-                <p14:modId xmlns:p14="http://schemas.microsoft.com/office/powerpoint/2010/main" val="3255027824"/>
+                <p14:modId xmlns:p14="http://schemas.microsoft.com/office/powerpoint/2010/main" val="1034184598"/>
               </p:ext>
             </p:extLst>
           </p:nvPr>
@@ -7431,7 +7337,7 @@
                       </a:pPr>
                       <a:r>
                         <a:rPr lang="en-US" dirty="0"/>
-                        <a:t>ChatGPT UI </a:t>
+                        <a:t>Basic paid plan for OpenAI, Anthropic and Google</a:t>
                       </a:r>
                     </a:p>
                     <a:p>
@@ -7441,7 +7347,7 @@
                       </a:pPr>
                       <a:r>
                         <a:rPr lang="en-US" dirty="0"/>
-                        <a:t>OpenAI Team Account</a:t>
+                        <a:t>Team accounts</a:t>
                       </a:r>
                     </a:p>
                     <a:p>
@@ -7451,21 +7357,7 @@
                       </a:pPr>
                       <a:r>
                         <a:rPr lang="en-US" dirty="0"/>
-                        <a:t>Institutional Access/Enterprise Contracts</a:t>
-                      </a:r>
-                    </a:p>
-                    <a:p>
-                      <a:pPr marL="742950" lvl="1" indent="-285750">
-                        <a:buFont typeface="Arial" panose="020B0604020202020204" pitchFamily="34" charset="0"/>
-                        <a:buChar char="•"/>
-                      </a:pPr>
-                      <a:r>
-                        <a:rPr lang="en-US" dirty="0" err="1"/>
-                        <a:t>vanderbilt.ai</a:t>
-                      </a:r>
-                      <a:r>
-                        <a:rPr lang="en-US" dirty="0"/>
-                        <a:t> (Amplify)</a:t>
+                        <a:t>Institutional Access (ChatGPT EDU)</a:t>
                       </a:r>
                     </a:p>
                     <a:p>
@@ -7495,7 +7387,7 @@
                       </a:pPr>
                       <a:r>
                         <a:rPr lang="en-US" dirty="0"/>
-                        <a:t>Local or hosted Vector Stores</a:t>
+                        <a:t>Local or hosted Vector Stores for RAG</a:t>
                       </a:r>
                     </a:p>
                     <a:p>
@@ -7551,8 +7443,13 @@
                       </a:pPr>
                       <a:r>
                         <a:rPr lang="en-US" dirty="0"/>
-                        <a:t>Access to closed source models only through enterprise contracts</a:t>
+                        <a:t>Access to closed source models only through enterprise contracts – </a:t>
                       </a:r>
+                      <a:r>
+                        <a:rPr lang="en-US" dirty="0" err="1"/>
+                        <a:t>Vanderbilt.ai</a:t>
+                      </a:r>
+                      <a:endParaRPr lang="en-US" dirty="0"/>
                     </a:p>
                     <a:p>
                       <a:pPr marL="285750" indent="-285750">
@@ -7581,7 +7478,7 @@
                       </a:pPr>
                       <a:r>
                         <a:rPr lang="en-US" dirty="0"/>
-                        <a:t>Local or approved Vector Stores</a:t>
+                        <a:t>Local or approved Vector Stores for RAG</a:t>
                       </a:r>
                     </a:p>
                     <a:p>
@@ -7657,7 +7554,7 @@
 </p:sld>
 </file>
 
-<file path=ppt/slides/slide7.xml><?xml version="1.0" encoding="utf-8"?>
+<file path=ppt/slides/slide8.xml><?xml version="1.0" encoding="utf-8"?>
 <p:sld xmlns:a="http://schemas.openxmlformats.org/drawingml/2006/main" xmlns:r="http://schemas.openxmlformats.org/officeDocument/2006/relationships" xmlns:p="http://schemas.openxmlformats.org/presentationml/2006/main">
   <p:cSld>
     <p:spTree>
@@ -7679,7 +7576,7 @@
           <p:cNvPr id="2" name="Title 1">
             <a:extLst>
               <a:ext uri="{FF2B5EF4-FFF2-40B4-BE49-F238E27FC236}">
-                <a16:creationId xmlns:a16="http://schemas.microsoft.com/office/drawing/2014/main" id="{FFD1BBFB-F61A-C92B-AB5C-628F48C4A82E}"/>
+                <a16:creationId xmlns:a16="http://schemas.microsoft.com/office/drawing/2014/main" id="{143758C0-6162-4AB7-B333-551256A9B9A6}"/>
               </a:ext>
             </a:extLst>
           </p:cNvPr>
@@ -7697,7 +7594,15 @@
           <a:p>
             <a:r>
               <a:rPr lang="en-US" dirty="0"/>
-              <a:t>Limitations of working locally</a:t>
+              <a:t>Where does Claude, </a:t>
+            </a:r>
+            <a:r>
+              <a:rPr lang="en-US" dirty="0" err="1"/>
+              <a:t>Cowork</a:t>
+            </a:r>
+            <a:r>
+              <a:rPr lang="en-US" dirty="0"/>
+              <a:t> and Code fit into this framework?</a:t>
             </a:r>
           </a:p>
         </p:txBody>
@@ -7707,7 +7612,7 @@
           <p:cNvPr id="3" name="Content Placeholder 2">
             <a:extLst>
               <a:ext uri="{FF2B5EF4-FFF2-40B4-BE49-F238E27FC236}">
-                <a16:creationId xmlns:a16="http://schemas.microsoft.com/office/drawing/2014/main" id="{6AFF03E2-0CE7-F8BD-8BE9-A1BDDEEEEEC4}"/>
+                <a16:creationId xmlns:a16="http://schemas.microsoft.com/office/drawing/2014/main" id="{32A368A8-E5E6-DD8B-31E4-CC4F886FF7B9}"/>
               </a:ext>
             </a:extLst>
           </p:cNvPr>
@@ -7721,69 +7626,66 @@
         <p:spPr/>
         <p:txBody>
           <a:bodyPr>
-            <a:normAutofit fontScale="92500"/>
+            <a:normAutofit fontScale="77500" lnSpcReduction="20000"/>
           </a:bodyPr>
           <a:lstStyle/>
           <a:p>
             <a:r>
               <a:rPr lang="en-US" dirty="0"/>
-              <a:t>Most open-source LLMs that you can run locally are not as good as state-of-the-art models like O1 and Claude 3.7, and proprietary models are almost never available to run locally (exception – </a:t>
+              <a:t>Standard unpaid plan – Level 1 data</a:t>
+            </a:r>
+          </a:p>
+          <a:p>
+            <a:endParaRPr lang="en-US" dirty="0"/>
+          </a:p>
+          <a:p>
+            <a:r>
+              <a:rPr lang="en-US" dirty="0"/>
+              <a:t>Standard paid plan with opt-out – Level 2 OR Level 3 – check with your institution. Current agreements with Anthropic allow use of Level 2 data with Claude at Vanderbilt or level 3 access to Anthropic models through </a:t>
             </a:r>
             <a:r>
               <a:rPr lang="en-US" dirty="0" err="1"/>
-              <a:t>DeepSeek</a:t>
+              <a:t>vanderbilt.ai</a:t>
             </a:r>
             <a:r>
               <a:rPr lang="en-US" dirty="0"/>
-              <a:t> R1)</a:t>
-            </a:r>
-          </a:p>
-          <a:p>
+              <a:t> (but not Claude Code or </a:t>
+            </a:r>
+            <a:r>
+              <a:rPr lang="en-US" dirty="0" err="1"/>
+              <a:t>Cowork</a:t>
+            </a:r>
             <a:r>
               <a:rPr lang="en-US" dirty="0"/>
-              <a:t>You are limited by your hardware – running or training full parameter large LLMs requires multiple GPU nodes, if not multiple racks</a:t>
-            </a:r>
-          </a:p>
-          <a:p>
-            <a:pPr lvl="1"/>
+              <a:t>)</a:t>
+            </a:r>
+          </a:p>
+          <a:p>
+            <a:endParaRPr lang="en-US" dirty="0"/>
+          </a:p>
+          <a:p>
             <a:r>
               <a:rPr lang="en-US" dirty="0"/>
-              <a:t>Solution?</a:t>
-            </a:r>
-          </a:p>
-          <a:p>
-            <a:pPr lvl="2"/>
+              <a:t>Working with more secure data? There are several alternatives to Claude code which mimic the multi-agent and system aware capabilities of Claude Code. One good alternative is </a:t>
+            </a:r>
+            <a:r>
+              <a:rPr lang="en-US" dirty="0">
+                <a:hlinkClick r:id="rId3"/>
+              </a:rPr>
+              <a:t>OpenCode</a:t>
+            </a:r>
             <a:r>
               <a:rPr lang="en-US" dirty="0"/>
-              <a:t>Enterprise contracts through AWS or Azure giving you a secure instance for popular proprietary LLMs</a:t>
-            </a:r>
-          </a:p>
-          <a:p>
-            <a:pPr lvl="2"/>
+              <a:t> that allows the use of models that run locally on your machine</a:t>
+            </a:r>
+          </a:p>
+          <a:p>
+            <a:endParaRPr lang="en-US" dirty="0"/>
+          </a:p>
+          <a:p>
             <a:r>
               <a:rPr lang="en-US" dirty="0"/>
-              <a:t>Use smaller parameter fine-tuned models</a:t>
-            </a:r>
-          </a:p>
-          <a:p>
-            <a:pPr lvl="2"/>
-            <a:r>
-              <a:rPr lang="en-US" dirty="0"/>
-              <a:t>Use distilled versions of larger models</a:t>
-            </a:r>
-          </a:p>
-          <a:p>
-            <a:pPr lvl="2"/>
-            <a:r>
-              <a:rPr lang="en-US" dirty="0"/>
-              <a:t>Use larger models with lower quantization </a:t>
-            </a:r>
-          </a:p>
-          <a:p>
-            <a:pPr lvl="2"/>
-            <a:r>
-              <a:rPr lang="en-US" dirty="0"/>
-              <a:t>PEFT</a:t>
+              <a:t>Level 4 data? You may need to build a custom solution to fit your needs. Instruction in week 2 will give you the tools necessary to build simple agentic workflows</a:t>
             </a:r>
           </a:p>
         </p:txBody>
@@ -7791,7 +7693,7 @@
     </p:spTree>
     <p:extLst>
       <p:ext uri="{BB962C8B-B14F-4D97-AF65-F5344CB8AC3E}">
-        <p14:creationId xmlns:p14="http://schemas.microsoft.com/office/powerpoint/2010/main" val="1755869152"/>
+        <p14:creationId xmlns:p14="http://schemas.microsoft.com/office/powerpoint/2010/main" val="4105020529"/>
       </p:ext>
     </p:extLst>
   </p:cSld>
@@ -7801,8 +7703,8 @@
 </p:sld>
 </file>
 
-<file path=ppt/slides/slide8.xml><?xml version="1.0" encoding="utf-8"?>
-<p:sld xmlns:a="http://schemas.openxmlformats.org/drawingml/2006/main" xmlns:r="http://schemas.openxmlformats.org/officeDocument/2006/relationships" xmlns:p="http://schemas.openxmlformats.org/presentationml/2006/main" show="0">
+<file path=ppt/slides/slide9.xml><?xml version="1.0" encoding="utf-8"?>
+<p:sld xmlns:a="http://schemas.openxmlformats.org/drawingml/2006/main" xmlns:r="http://schemas.openxmlformats.org/officeDocument/2006/relationships" xmlns:p="http://schemas.openxmlformats.org/presentationml/2006/main">
   <p:cSld>
     <p:spTree>
       <p:nvGrpSpPr>
@@ -7820,10 +7722,38 @@
       </p:grpSpPr>
       <p:sp>
         <p:nvSpPr>
+          <p:cNvPr id="2" name="Title 1">
+            <a:extLst>
+              <a:ext uri="{FF2B5EF4-FFF2-40B4-BE49-F238E27FC236}">
+                <a16:creationId xmlns:a16="http://schemas.microsoft.com/office/drawing/2014/main" id="{FFD1BBFB-F61A-C92B-AB5C-628F48C4A82E}"/>
+              </a:ext>
+            </a:extLst>
+          </p:cNvPr>
+          <p:cNvSpPr>
+            <a:spLocks noGrp="1"/>
+          </p:cNvSpPr>
+          <p:nvPr>
+            <p:ph type="title"/>
+          </p:nvPr>
+        </p:nvSpPr>
+        <p:spPr/>
+        <p:txBody>
+          <a:bodyPr/>
+          <a:lstStyle/>
+          <a:p>
+            <a:r>
+              <a:rPr lang="en-US" dirty="0"/>
+              <a:t>Limitations of working locally</a:t>
+            </a:r>
+          </a:p>
+        </p:txBody>
+      </p:sp>
+      <p:sp>
+        <p:nvSpPr>
           <p:cNvPr id="3" name="Content Placeholder 2">
             <a:extLst>
               <a:ext uri="{FF2B5EF4-FFF2-40B4-BE49-F238E27FC236}">
-                <a16:creationId xmlns:a16="http://schemas.microsoft.com/office/drawing/2014/main" id="{AF8B672E-6D12-C3B6-C3BF-85E5B062841E}"/>
+                <a16:creationId xmlns:a16="http://schemas.microsoft.com/office/drawing/2014/main" id="{6AFF03E2-0CE7-F8BD-8BE9-A1BDDEEEEEC4}"/>
               </a:ext>
             </a:extLst>
           </p:cNvPr>
@@ -7834,203 +7764,65 @@
             <p:ph idx="1"/>
           </p:nvPr>
         </p:nvSpPr>
-        <p:spPr>
-          <a:xfrm>
-            <a:off x="838200" y="543697"/>
-            <a:ext cx="10515600" cy="5633266"/>
-          </a:xfrm>
-        </p:spPr>
-        <p:txBody>
-          <a:bodyPr/>
+        <p:spPr/>
+        <p:txBody>
+          <a:bodyPr>
+            <a:normAutofit/>
+          </a:bodyPr>
           <a:lstStyle/>
           <a:p>
             <a:r>
               <a:rPr lang="en-US" dirty="0"/>
-              <a:t>Quantization: A technique used to reduce the memory footprint and computational cost of running large-scale neural networks by representing weights and activations with lower precision numerical formats (e.g., reducing from 32-bit floating point (FP32) to 8-bit integers (INT8) or lower).</a:t>
-            </a:r>
-          </a:p>
-          <a:p>
-            <a:endParaRPr lang="en-US" dirty="0"/>
+              <a:t>Most open-source LLMs that you can run locally are not as good as state-of-the-art models like O1 and Claude 3.7, and proprietary models are almost never available to run locally </a:t>
+            </a:r>
+          </a:p>
+          <a:p>
+            <a:r>
+              <a:rPr lang="en-US" dirty="0"/>
+              <a:t>You are limited by your hardware – running or training full parameter large LLMs requires multiple GPU nodes, if not multiple racks</a:t>
+            </a:r>
           </a:p>
           <a:p>
             <a:pPr lvl="1"/>
             <a:r>
-              <a:rPr lang="en-US" b="1" dirty="0"/>
-              <a:t>Reducing Model Size </a:t>
-            </a:r>
-            <a:r>
               <a:rPr lang="en-US" dirty="0"/>
-              <a:t>– Uses less memory, allowing models to fit into smaller hardware (e.g., edge devices, consumer GPUs).</a:t>
-            </a:r>
-          </a:p>
-          <a:p>
-            <a:pPr lvl="1"/>
-            <a:r>
-              <a:rPr lang="en-US" b="1" dirty="0"/>
-              <a:t>Speeding Up Inference </a:t>
-            </a:r>
+              <a:t>Solution?</a:t>
+            </a:r>
+          </a:p>
+          <a:p>
+            <a:pPr lvl="2"/>
             <a:r>
               <a:rPr lang="en-US" dirty="0"/>
-              <a:t>– Lower precision calculations are faster and consume less power.</a:t>
-            </a:r>
-          </a:p>
-          <a:p>
-            <a:pPr lvl="1"/>
-            <a:r>
-              <a:rPr lang="en-US" b="1" dirty="0"/>
-              <a:t>Lowering Latency </a:t>
-            </a:r>
+              <a:t>Use smaller parameter fine-tuned models</a:t>
+            </a:r>
+          </a:p>
+          <a:p>
+            <a:pPr lvl="2"/>
             <a:r>
               <a:rPr lang="en-US" dirty="0"/>
-              <a:t>– Essential for real-time applications like chatbots and AI assistants.</a:t>
-            </a:r>
-          </a:p>
-          <a:p>
-            <a:pPr lvl="1"/>
-            <a:r>
-              <a:rPr lang="en-US" b="1" dirty="0"/>
-              <a:t>Reducing Energy Consumption </a:t>
-            </a:r>
+              <a:t>Use distilled versions of larger models</a:t>
+            </a:r>
+          </a:p>
+          <a:p>
+            <a:pPr lvl="2"/>
             <a:r>
               <a:rPr lang="en-US" dirty="0"/>
-              <a:t>– Helps deploy AI models more efficiently on constrained hardware.</a:t>
-            </a:r>
-          </a:p>
-          <a:p>
-            <a:pPr lvl="1"/>
-            <a:endParaRPr lang="en-US" dirty="0"/>
+              <a:t>Use larger models with lower quantization </a:t>
+            </a:r>
+          </a:p>
+          <a:p>
+            <a:pPr lvl="2"/>
+            <a:r>
+              <a:rPr lang="en-US" dirty="0"/>
+              <a:t>PEFT for training</a:t>
+            </a:r>
           </a:p>
         </p:txBody>
       </p:sp>
     </p:spTree>
     <p:extLst>
       <p:ext uri="{BB962C8B-B14F-4D97-AF65-F5344CB8AC3E}">
-        <p14:creationId xmlns:p14="http://schemas.microsoft.com/office/powerpoint/2010/main" val="2670362181"/>
-      </p:ext>
-    </p:extLst>
-  </p:cSld>
-  <p:clrMapOvr>
-    <a:masterClrMapping/>
-  </p:clrMapOvr>
-</p:sld>
-</file>
-
-<file path=ppt/slides/slide9.xml><?xml version="1.0" encoding="utf-8"?>
-<p:sld xmlns:a="http://schemas.openxmlformats.org/drawingml/2006/main" xmlns:r="http://schemas.openxmlformats.org/officeDocument/2006/relationships" xmlns:p="http://schemas.openxmlformats.org/presentationml/2006/main" show="0">
-  <p:cSld>
-    <p:spTree>
-      <p:nvGrpSpPr>
-        <p:cNvPr id="1" name=""/>
-        <p:cNvGrpSpPr/>
-        <p:nvPr/>
-      </p:nvGrpSpPr>
-      <p:grpSpPr>
-        <a:xfrm>
-          <a:off x="0" y="0"/>
-          <a:ext cx="0" cy="0"/>
-          <a:chOff x="0" y="0"/>
-          <a:chExt cx="0" cy="0"/>
-        </a:xfrm>
-      </p:grpSpPr>
-      <p:sp>
-        <p:nvSpPr>
-          <p:cNvPr id="3" name="Content Placeholder 2">
-            <a:extLst>
-              <a:ext uri="{FF2B5EF4-FFF2-40B4-BE49-F238E27FC236}">
-                <a16:creationId xmlns:a16="http://schemas.microsoft.com/office/drawing/2014/main" id="{940AD986-048E-A178-45CE-5B8CCD35EC8E}"/>
-              </a:ext>
-            </a:extLst>
-          </p:cNvPr>
-          <p:cNvSpPr>
-            <a:spLocks noGrp="1"/>
-          </p:cNvSpPr>
-          <p:nvPr>
-            <p:ph idx="1"/>
-          </p:nvPr>
-        </p:nvSpPr>
-        <p:spPr>
-          <a:xfrm>
-            <a:off x="838200" y="531341"/>
-            <a:ext cx="10515600" cy="5645622"/>
-          </a:xfrm>
-        </p:spPr>
-        <p:txBody>
-          <a:bodyPr>
-            <a:normAutofit fontScale="92500" lnSpcReduction="10000"/>
-          </a:bodyPr>
-          <a:lstStyle/>
-          <a:p>
-            <a:r>
-              <a:rPr lang="en-US" dirty="0"/>
-              <a:t>Distillation: A knowledge transfer technique where a smaller, more efficient model (student model) learns from a larger, more powerful model (teacher model). This process helps compress the knowledge of the large model into a smaller one while maintaining performance.</a:t>
-            </a:r>
-          </a:p>
-          <a:p>
-            <a:endParaRPr lang="en-US" dirty="0"/>
-          </a:p>
-          <a:p>
-            <a:r>
-              <a:rPr lang="en-US" dirty="0"/>
-              <a:t>How Distillation Works in LLMs:</a:t>
-            </a:r>
-          </a:p>
-          <a:p>
-            <a:endParaRPr lang="en-US" dirty="0"/>
-          </a:p>
-          <a:p>
-            <a:pPr lvl="1"/>
-            <a:r>
-              <a:rPr lang="en-US" b="1" dirty="0"/>
-              <a:t>Training a Large Teacher </a:t>
-            </a:r>
-            <a:r>
-              <a:rPr lang="en-US" dirty="0"/>
-              <a:t>Model – A large LLM is first pre-trained on vast amounts of data.</a:t>
-            </a:r>
-          </a:p>
-          <a:p>
-            <a:pPr lvl="1"/>
-            <a:r>
-              <a:rPr lang="en-US" b="1" dirty="0"/>
-              <a:t>Training a Smaller Student </a:t>
-            </a:r>
-            <a:r>
-              <a:rPr lang="en-US" dirty="0"/>
-              <a:t>Model – Instead of training from scratch, the student model learns from the outputs (soft labels, logits, hidden representations) of the teacher model.</a:t>
-            </a:r>
-          </a:p>
-          <a:p>
-            <a:pPr lvl="1"/>
-            <a:r>
-              <a:rPr lang="en-US" b="1" dirty="0"/>
-              <a:t>Matching the Teacher’s Behavior </a:t>
-            </a:r>
-            <a:r>
-              <a:rPr lang="en-US" dirty="0"/>
-              <a:t>– The student model optimizes its parameters to mimic the teacher model’s responses, probabilities, or intermediate representations.</a:t>
-            </a:r>
-          </a:p>
-          <a:p>
-            <a:pPr lvl="1"/>
-            <a:r>
-              <a:rPr lang="en-US" b="1" dirty="0"/>
-              <a:t>Fine-tuning for Specific Tasks </a:t>
-            </a:r>
-            <a:r>
-              <a:rPr lang="en-US" dirty="0"/>
-              <a:t>– The student model is further fine-tuned to maintain high accuracy on key tasks while being much smaller and faster.</a:t>
-            </a:r>
-          </a:p>
-          <a:p>
-            <a:pPr lvl="1"/>
-            <a:endParaRPr lang="en-US" dirty="0"/>
-          </a:p>
-        </p:txBody>
-      </p:sp>
-    </p:spTree>
-    <p:extLst>
-      <p:ext uri="{BB962C8B-B14F-4D97-AF65-F5344CB8AC3E}">
-        <p14:creationId xmlns:p14="http://schemas.microsoft.com/office/powerpoint/2010/main" val="4129932934"/>
+        <p14:creationId xmlns:p14="http://schemas.microsoft.com/office/powerpoint/2010/main" val="1755869152"/>
       </p:ext>
     </p:extLst>
   </p:cSld>

</xml_diff>